<commit_message>
Add 'why learn it' motivation slide (intractable high-color limit framing)
Co-Authored-By: Claude Fable 5 <noreply@anthropic.com>
</commit_message>
<xml_diff>
--- a/Jones_phase_feature.pptx
+++ b/Jones_phase_feature.pptx
@@ -8,19 +8,20 @@
     <p:sldId id="256" r:id="rId7"/>
     <p:sldId id="257" r:id="rId8"/>
     <p:sldId id="258" r:id="rId9"/>
-    <p:sldId id="259" r:id="rId10"/>
-    <p:sldId id="260" r:id="rId11"/>
-    <p:sldId id="261" r:id="rId12"/>
-    <p:sldId id="262" r:id="rId13"/>
-    <p:sldId id="263" r:id="rId14"/>
-    <p:sldId id="264" r:id="rId15"/>
-    <p:sldId id="265" r:id="rId16"/>
-    <p:sldId id="266" r:id="rId17"/>
-    <p:sldId id="267" r:id="rId18"/>
-    <p:sldId id="268" r:id="rId19"/>
-    <p:sldId id="269" r:id="rId20"/>
-    <p:sldId id="270" r:id="rId21"/>
-    <p:sldId id="271" r:id="rId22"/>
+    <p:sldId id="259" r:id="rId11"/>
+    <p:sldId id="260" r:id="rId12"/>
+    <p:sldId id="261" r:id="rId13"/>
+    <p:sldId id="262" r:id="rId14"/>
+    <p:sldId id="263" r:id="rId15"/>
+    <p:sldId id="264" r:id="rId16"/>
+    <p:sldId id="265" r:id="rId17"/>
+    <p:sldId id="266" r:id="rId18"/>
+    <p:sldId id="267" r:id="rId19"/>
+    <p:sldId id="268" r:id="rId20"/>
+    <p:sldId id="269" r:id="rId21"/>
+    <p:sldId id="270" r:id="rId22"/>
+    <p:sldId id="271" r:id="rId23"/>
+    <p:sldId id="272" r:id="rId24"/>
   </p:sldIdLst>
   <p:sldSz cx="12191695" cy="6858000" type="screen4x3"/>
   <p:notesSz cx="6858000" cy="9144000"/>
@@ -120,6 +121,426 @@
     </a:lvl9pPr>
   </p:defaultTextStyle>
 </p:presentation>
+</file>
+
+<file path=ppt/notesMasters/notesMaster1.xml><?xml version="1.0" encoding="utf-8"?>
+<p:notesMaster xmlns:a="http://schemas.openxmlformats.org/drawingml/2006/main" xmlns:p="http://schemas.openxmlformats.org/presentationml/2006/main" xmlns:r="http://schemas.openxmlformats.org/officeDocument/2006/relationships">
+  <p:cSld>
+    <p:bg>
+      <p:bgRef idx="1001">
+        <a:schemeClr val="bg1"/>
+      </p:bgRef>
+    </p:bg>
+    <p:spTree>
+      <p:nvGrpSpPr>
+        <p:cNvPr id="1" name=""/>
+        <p:cNvGrpSpPr/>
+        <p:nvPr/>
+      </p:nvGrpSpPr>
+      <p:grpSpPr>
+        <a:xfrm>
+          <a:off x="0" y="0"/>
+          <a:ext cx="0" cy="0"/>
+          <a:chOff x="0" y="0"/>
+          <a:chExt cx="0" cy="0"/>
+        </a:xfrm>
+      </p:grpSpPr>
+      <p:sp>
+        <p:nvSpPr>
+          <p:cNvPr id="2" name="Header Placeholder 1"/>
+          <p:cNvSpPr>
+            <a:spLocks noGrp="1"/>
+          </p:cNvSpPr>
+          <p:nvPr>
+            <p:ph type="hdr" sz="quarter"/>
+          </p:nvPr>
+        </p:nvSpPr>
+        <p:spPr>
+          <a:xfrm>
+            <a:off x="0" y="0"/>
+            <a:ext cx="2971800" cy="457200"/>
+          </a:xfrm>
+          <a:prstGeom prst="rect">
+            <a:avLst/>
+          </a:prstGeom>
+        </p:spPr>
+        <p:txBody>
+          <a:bodyPr vert="horz" lIns="91440" tIns="45720" rIns="91440" bIns="45720" rtlCol="0"/>
+          <a:lstStyle>
+            <a:lvl1pPr algn="l">
+              <a:defRPr sz="1200"/>
+            </a:lvl1pPr>
+          </a:lstStyle>
+          <a:p>
+            <a:endParaRPr lang="en-US"/>
+          </a:p>
+        </p:txBody>
+      </p:sp>
+      <p:sp>
+        <p:nvSpPr>
+          <p:cNvPr id="3" name="Date Placeholder 2"/>
+          <p:cNvSpPr>
+            <a:spLocks noGrp="1"/>
+          </p:cNvSpPr>
+          <p:nvPr>
+            <p:ph type="dt" idx="1"/>
+          </p:nvPr>
+        </p:nvSpPr>
+        <p:spPr>
+          <a:xfrm>
+            <a:off x="3884613" y="0"/>
+            <a:ext cx="2971800" cy="457200"/>
+          </a:xfrm>
+          <a:prstGeom prst="rect">
+            <a:avLst/>
+          </a:prstGeom>
+        </p:spPr>
+        <p:txBody>
+          <a:bodyPr vert="horz" lIns="91440" tIns="45720" rIns="91440" bIns="45720" rtlCol="0"/>
+          <a:lstStyle>
+            <a:lvl1pPr algn="r">
+              <a:defRPr sz="1200"/>
+            </a:lvl1pPr>
+          </a:lstStyle>
+          <a:p>
+            <a:fld id="{0F89C1C7-3DCD-1040-A9CF-14679D8B5DDD}" type="datetimeFigureOut">
+              <a:rPr lang="en-US" smtClean="0"/>
+              <a:t>10/17/16</a:t>
+            </a:fld>
+            <a:endParaRPr lang="en-US"/>
+          </a:p>
+        </p:txBody>
+      </p:sp>
+      <p:sp>
+        <p:nvSpPr>
+          <p:cNvPr id="4" name="Slide Image Placeholder 3"/>
+          <p:cNvSpPr>
+            <a:spLocks noGrp="1" noRot="1" noChangeAspect="1"/>
+          </p:cNvSpPr>
+          <p:nvPr>
+            <p:ph type="sldImg" idx="2"/>
+          </p:nvPr>
+        </p:nvSpPr>
+        <p:spPr>
+          <a:xfrm>
+            <a:off x="1143000" y="685800"/>
+            <a:ext cx="4572000" cy="3429000"/>
+          </a:xfrm>
+          <a:prstGeom prst="rect">
+            <a:avLst/>
+          </a:prstGeom>
+          <a:noFill/>
+          <a:ln w="12700">
+            <a:solidFill>
+              <a:prstClr val="black"/>
+            </a:solidFill>
+          </a:ln>
+        </p:spPr>
+        <p:txBody>
+          <a:bodyPr vert="horz" lIns="91440" tIns="45720" rIns="91440" bIns="45720" rtlCol="0" anchor="ctr"/>
+          <a:lstStyle/>
+          <a:p>
+            <a:endParaRPr lang="en-US"/>
+          </a:p>
+        </p:txBody>
+      </p:sp>
+      <p:sp>
+        <p:nvSpPr>
+          <p:cNvPr id="5" name="Notes Placeholder 4"/>
+          <p:cNvSpPr>
+            <a:spLocks noGrp="1"/>
+          </p:cNvSpPr>
+          <p:nvPr>
+            <p:ph type="body" sz="quarter" idx="3"/>
+          </p:nvPr>
+        </p:nvSpPr>
+        <p:spPr>
+          <a:xfrm>
+            <a:off x="685800" y="4343400"/>
+            <a:ext cx="5486400" cy="4114800"/>
+          </a:xfrm>
+          <a:prstGeom prst="rect">
+            <a:avLst/>
+          </a:prstGeom>
+        </p:spPr>
+        <p:txBody>
+          <a:bodyPr vert="horz" lIns="91440" tIns="45720" rIns="91440" bIns="45720" rtlCol="0"/>
+          <a:lstStyle/>
+          <a:p>
+            <a:pPr lvl="0"/>
+            <a:r>
+              <a:rPr lang="en-US" smtClean="0"/>
+              <a:t>Click to edit Master text styles</a:t>
+            </a:r>
+          </a:p>
+          <a:p>
+            <a:pPr lvl="1"/>
+            <a:r>
+              <a:rPr lang="en-US" smtClean="0"/>
+              <a:t>Second level</a:t>
+            </a:r>
+          </a:p>
+          <a:p>
+            <a:pPr lvl="2"/>
+            <a:r>
+              <a:rPr lang="en-US" smtClean="0"/>
+              <a:t>Third level</a:t>
+            </a:r>
+          </a:p>
+          <a:p>
+            <a:pPr lvl="3"/>
+            <a:r>
+              <a:rPr lang="en-US" smtClean="0"/>
+              <a:t>Fourth level</a:t>
+            </a:r>
+          </a:p>
+          <a:p>
+            <a:pPr lvl="4"/>
+            <a:r>
+              <a:rPr lang="en-US" smtClean="0"/>
+              <a:t>Fifth level</a:t>
+            </a:r>
+            <a:endParaRPr lang="en-US"/>
+          </a:p>
+        </p:txBody>
+      </p:sp>
+      <p:sp>
+        <p:nvSpPr>
+          <p:cNvPr id="6" name="Footer Placeholder 5"/>
+          <p:cNvSpPr>
+            <a:spLocks noGrp="1"/>
+          </p:cNvSpPr>
+          <p:nvPr>
+            <p:ph type="ftr" sz="quarter" idx="4"/>
+          </p:nvPr>
+        </p:nvSpPr>
+        <p:spPr>
+          <a:xfrm>
+            <a:off x="0" y="8685213"/>
+            <a:ext cx="2971800" cy="457200"/>
+          </a:xfrm>
+          <a:prstGeom prst="rect">
+            <a:avLst/>
+          </a:prstGeom>
+        </p:spPr>
+        <p:txBody>
+          <a:bodyPr vert="horz" lIns="91440" tIns="45720" rIns="91440" bIns="45720" rtlCol="0" anchor="b"/>
+          <a:lstStyle>
+            <a:lvl1pPr algn="l">
+              <a:defRPr sz="1200"/>
+            </a:lvl1pPr>
+          </a:lstStyle>
+          <a:p>
+            <a:endParaRPr lang="en-US"/>
+          </a:p>
+        </p:txBody>
+      </p:sp>
+      <p:sp>
+        <p:nvSpPr>
+          <p:cNvPr id="7" name="Slide Number Placeholder 6"/>
+          <p:cNvSpPr>
+            <a:spLocks noGrp="1"/>
+          </p:cNvSpPr>
+          <p:nvPr>
+            <p:ph type="sldNum" sz="quarter" idx="5"/>
+          </p:nvPr>
+        </p:nvSpPr>
+        <p:spPr>
+          <a:xfrm>
+            <a:off x="3884613" y="8685213"/>
+            <a:ext cx="2971800" cy="457200"/>
+          </a:xfrm>
+          <a:prstGeom prst="rect">
+            <a:avLst/>
+          </a:prstGeom>
+        </p:spPr>
+        <p:txBody>
+          <a:bodyPr vert="horz" lIns="91440" tIns="45720" rIns="91440" bIns="45720" rtlCol="0" anchor="b"/>
+          <a:lstStyle>
+            <a:lvl1pPr algn="r">
+              <a:defRPr sz="1200"/>
+            </a:lvl1pPr>
+          </a:lstStyle>
+          <a:p>
+            <a:fld id="{BB5E49A5-4136-284D-997B-48E1D791AD67}" type="slidenum">
+              <a:rPr lang="en-US" smtClean="0"/>
+              <a:t>‹#›</a:t>
+            </a:fld>
+            <a:endParaRPr lang="en-US"/>
+          </a:p>
+        </p:txBody>
+      </p:sp>
+    </p:spTree>
+    <p:extLst>
+      <p:ext uri="{BB962C8B-B14F-4D97-AF65-F5344CB8AC3E}">
+        <p14:creationId xmlns:p14="http://schemas.microsoft.com/office/powerpoint/2010/main" val="2623252185"/>
+      </p:ext>
+    </p:extLst>
+  </p:cSld>
+  <p:clrMap bg1="lt1" tx1="dk1" bg2="lt2" tx2="dk2" accent1="accent1" accent2="accent2" accent3="accent3" accent4="accent4" accent5="accent5" accent6="accent6" hlink="hlink" folHlink="folHlink"/>
+  <p:notesStyle>
+    <a:lvl1pPr marL="0" algn="l" defTabSz="457200" rtl="0" eaLnBrk="1" latinLnBrk="0" hangingPunct="1">
+      <a:defRPr sz="1200" kern="1200">
+        <a:solidFill>
+          <a:schemeClr val="tx1"/>
+        </a:solidFill>
+        <a:latin typeface="+mn-lt"/>
+        <a:ea typeface="+mn-ea"/>
+        <a:cs typeface="+mn-cs"/>
+      </a:defRPr>
+    </a:lvl1pPr>
+    <a:lvl2pPr marL="457200" algn="l" defTabSz="457200" rtl="0" eaLnBrk="1" latinLnBrk="0" hangingPunct="1">
+      <a:defRPr sz="1200" kern="1200">
+        <a:solidFill>
+          <a:schemeClr val="tx1"/>
+        </a:solidFill>
+        <a:latin typeface="+mn-lt"/>
+        <a:ea typeface="+mn-ea"/>
+        <a:cs typeface="+mn-cs"/>
+      </a:defRPr>
+    </a:lvl2pPr>
+    <a:lvl3pPr marL="914400" algn="l" defTabSz="457200" rtl="0" eaLnBrk="1" latinLnBrk="0" hangingPunct="1">
+      <a:defRPr sz="1200" kern="1200">
+        <a:solidFill>
+          <a:schemeClr val="tx1"/>
+        </a:solidFill>
+        <a:latin typeface="+mn-lt"/>
+        <a:ea typeface="+mn-ea"/>
+        <a:cs typeface="+mn-cs"/>
+      </a:defRPr>
+    </a:lvl3pPr>
+    <a:lvl4pPr marL="1371600" algn="l" defTabSz="457200" rtl="0" eaLnBrk="1" latinLnBrk="0" hangingPunct="1">
+      <a:defRPr sz="1200" kern="1200">
+        <a:solidFill>
+          <a:schemeClr val="tx1"/>
+        </a:solidFill>
+        <a:latin typeface="+mn-lt"/>
+        <a:ea typeface="+mn-ea"/>
+        <a:cs typeface="+mn-cs"/>
+      </a:defRPr>
+    </a:lvl4pPr>
+    <a:lvl5pPr marL="1828800" algn="l" defTabSz="457200" rtl="0" eaLnBrk="1" latinLnBrk="0" hangingPunct="1">
+      <a:defRPr sz="1200" kern="1200">
+        <a:solidFill>
+          <a:schemeClr val="tx1"/>
+        </a:solidFill>
+        <a:latin typeface="+mn-lt"/>
+        <a:ea typeface="+mn-ea"/>
+        <a:cs typeface="+mn-cs"/>
+      </a:defRPr>
+    </a:lvl5pPr>
+    <a:lvl6pPr marL="2286000" algn="l" defTabSz="457200" rtl="0" eaLnBrk="1" latinLnBrk="0" hangingPunct="1">
+      <a:defRPr sz="1200" kern="1200">
+        <a:solidFill>
+          <a:schemeClr val="tx1"/>
+        </a:solidFill>
+        <a:latin typeface="+mn-lt"/>
+        <a:ea typeface="+mn-ea"/>
+        <a:cs typeface="+mn-cs"/>
+      </a:defRPr>
+    </a:lvl6pPr>
+    <a:lvl7pPr marL="2743200" algn="l" defTabSz="457200" rtl="0" eaLnBrk="1" latinLnBrk="0" hangingPunct="1">
+      <a:defRPr sz="1200" kern="1200">
+        <a:solidFill>
+          <a:schemeClr val="tx1"/>
+        </a:solidFill>
+        <a:latin typeface="+mn-lt"/>
+        <a:ea typeface="+mn-ea"/>
+        <a:cs typeface="+mn-cs"/>
+      </a:defRPr>
+    </a:lvl7pPr>
+    <a:lvl8pPr marL="3200400" algn="l" defTabSz="457200" rtl="0" eaLnBrk="1" latinLnBrk="0" hangingPunct="1">
+      <a:defRPr sz="1200" kern="1200">
+        <a:solidFill>
+          <a:schemeClr val="tx1"/>
+        </a:solidFill>
+        <a:latin typeface="+mn-lt"/>
+        <a:ea typeface="+mn-ea"/>
+        <a:cs typeface="+mn-cs"/>
+      </a:defRPr>
+    </a:lvl8pPr>
+    <a:lvl9pPr marL="3657600" algn="l" defTabSz="457200" rtl="0" eaLnBrk="1" latinLnBrk="0" hangingPunct="1">
+      <a:defRPr sz="1200" kern="1200">
+        <a:solidFill>
+          <a:schemeClr val="tx1"/>
+        </a:solidFill>
+        <a:latin typeface="+mn-lt"/>
+        <a:ea typeface="+mn-ea"/>
+        <a:cs typeface="+mn-cs"/>
+      </a:defRPr>
+    </a:lvl9pPr>
+  </p:notesStyle>
+</p:notesMaster>
+</file>
+
+<file path=ppt/notesSlides/notesSlide1.xml><?xml version="1.0" encoding="utf-8"?>
+<p:notes xmlns:a="http://schemas.openxmlformats.org/drawingml/2006/main" xmlns:p="http://schemas.openxmlformats.org/presentationml/2006/main" xmlns:r="http://schemas.openxmlformats.org/officeDocument/2006/relationships">
+  <p:cSld>
+    <p:spTree>
+      <p:nvGrpSpPr>
+        <p:cNvPr id="1" name=""/>
+        <p:cNvGrpSpPr/>
+        <p:nvPr/>
+      </p:nvGrpSpPr>
+      <p:grpSpPr>
+        <a:xfrm>
+          <a:off x="0" y="0"/>
+          <a:ext cx="0" cy="0"/>
+          <a:chOff x="0" y="0"/>
+          <a:chExt cx="0" cy="0"/>
+        </a:xfrm>
+      </p:grpSpPr>
+      <p:sp>
+        <p:nvSpPr>
+          <p:cNvPr id="2" name="Slide Image Placeholder 1"/>
+          <p:cNvSpPr>
+            <a:spLocks noGrp="1"/>
+          </p:cNvSpPr>
+          <p:nvPr>
+            <p:ph type="sldImg" idx="2"/>
+          </p:nvPr>
+        </p:nvSpPr>
+        <p:spPr/>
+      </p:sp>
+      <p:sp>
+        <p:nvSpPr>
+          <p:cNvPr id="3" name="Notes Placeholder 2"/>
+          <p:cNvSpPr>
+            <a:spLocks noGrp="1"/>
+          </p:cNvSpPr>
+          <p:nvPr>
+            <p:ph type="body" idx="3" sz="quarter"/>
+          </p:nvPr>
+        </p:nvSpPr>
+        <p:spPr/>
+        <p:txBody>
+          <a:bodyPr/>
+          <a:lstStyle/>
+          <a:p>
+            <a:r>
+              <a:t>Computing the Jones polynomial at low color (J2, or J2+J3) is cheap, but the volume conjecture's actual claim only holds in the limit of infinitely high color — a regime that's computationally intractable to reach directly. Rather than chasing that limit, this approach trains a network on cheap, low-color data paired with independently computed ground-truth volumes. The network learns, empirically, whatever complex relationship links these low-level polynomial coefficients to the high-level geometric quantity of volume. In effect, it substitutes learned pattern-recognition for the intractable exact computation, extracting at inference time in a single forward pass what would otherwise require an infeasible high-color limit. The result is a model that operates cheaply at the low level but effectively captures and exploits structure that only becomes meaningful at the higher level. A further extension would push this idea one level higher — training a network to predict the volume-correlated behavior of higher-color polynomials (J4, J5, …) directly from cheap low-color data, avoiding their direct computation entirely rather than merely avoiding the infinite-N limit.</a:t>
+            </a:r>
+          </a:p>
+        </p:txBody>
+      </p:sp>
+      <p:sp>
+        <p:nvSpPr>
+          <p:cNvPr id="4" name="Slide Number Placeholder 3"/>
+          <p:cNvSpPr>
+            <a:spLocks noGrp="1"/>
+          </p:cNvSpPr>
+          <p:nvPr>
+            <p:ph type="sldNum" idx="5" sz="quarter"/>
+          </p:nvPr>
+        </p:nvSpPr>
+        <p:spPr/>
+      </p:sp>
+    </p:spTree>
+  </p:cSld>
+  <p:clrMapOvr>
+    <a:masterClrMapping/>
+  </p:clrMapOvr>
+</p:notes>
 </file>
 
 <file path=ppt/slideLayouts/slideLayout1.xml><?xml version="1.0" encoding="utf-8"?>
@@ -3238,7 +3659,7 @@
             <a:avLst/>
           </a:prstGeom>
           <a:solidFill>
-            <a:srgbClr val="0072B2"/>
+            <a:srgbClr val="D55E00"/>
           </a:solidFill>
           <a:ln>
             <a:noFill/>
@@ -3300,21 +3721,373 @@
                 </a:solidFill>
                 <a:latin typeface="Calibri"/>
               </a:rPr>
-              <a:t>Part II (measured): the adjoint J₃ on a colored-Jones dataset</a:t>
-            </a:r>
-          </a:p>
-        </p:txBody>
-      </p:sp>
-      <p:sp>
-        <p:nvSpPr>
-          <p:cNvPr id="4" name="TextBox 3"/>
+              <a:t>An information ceiling — and how to break it</a:t>
+            </a:r>
+          </a:p>
+        </p:txBody>
+      </p:sp>
+      <p:graphicFrame>
+        <p:nvGraphicFramePr>
+          <p:cNvPr id="4" name="Table 3"/>
+          <p:cNvGraphicFramePr>
+            <a:graphicFrameLocks noGrp="1"/>
+          </p:cNvGraphicFramePr>
+          <p:nvPr/>
+        </p:nvGraphicFramePr>
+        <p:xfrm>
+          <a:off x="777240" y="1371600"/>
+          <a:ext cx="10607040" cy="2651760"/>
+        </p:xfrm>
+        <a:graphic>
+          <a:graphicData uri="http://schemas.openxmlformats.org/drawingml/2006/table">
+            <a:tbl>
+              <a:tblPr firstRow="1" bandRow="1">
+                <a:tableStyleId>{5C22544A-7EE6-4342-B048-85BDC9FD1C3A}</a:tableStyleId>
+              </a:tblPr>
+              <a:tblGrid>
+                <a:gridCol w="4206240"/>
+                <a:gridCol w="3291840"/>
+                <a:gridCol w="3108960"/>
+              </a:tblGrid>
+              <a:tr h="530352">
+                <a:tc>
+                  <a:txBody>
+                    <a:bodyPr/>
+                    <a:lstStyle/>
+                    <a:p>
+                      <a:r>
+                        <a:rPr b="1" sz="1600">
+                          <a:solidFill>
+                            <a:srgbClr val="FFFFFF"/>
+                          </a:solidFill>
+                        </a:rPr>
+                        <a:t>Input</a:t>
+                      </a:r>
+                    </a:p>
+                  </a:txBody>
+                  <a:tcPr>
+                    <a:solidFill>
+                      <a:srgbClr val="0072B2"/>
+                    </a:solidFill>
+                  </a:tcPr>
+                </a:tc>
+                <a:tc>
+                  <a:txBody>
+                    <a:bodyPr/>
+                    <a:lstStyle/>
+                    <a:p>
+                      <a:r>
+                        <a:rPr b="1" sz="1600">
+                          <a:solidFill>
+                            <a:srgbClr val="FFFFFF"/>
+                          </a:solidFill>
+                        </a:rPr>
+                        <a:t>Dataset</a:t>
+                      </a:r>
+                    </a:p>
+                  </a:txBody>
+                  <a:tcPr>
+                    <a:solidFill>
+                      <a:srgbClr val="0072B2"/>
+                    </a:solidFill>
+                  </a:tcPr>
+                </a:tc>
+                <a:tc>
+                  <a:txBody>
+                    <a:bodyPr/>
+                    <a:lstStyle/>
+                    <a:p>
+                      <a:r>
+                        <a:rPr b="1" sz="1600">
+                          <a:solidFill>
+                            <a:srgbClr val="FFFFFF"/>
+                          </a:solidFill>
+                        </a:rPr>
+                        <a:t>Accuracy (1 − MRE)</a:t>
+                      </a:r>
+                    </a:p>
+                  </a:txBody>
+                  <a:tcPr>
+                    <a:solidFill>
+                      <a:srgbClr val="0072B2"/>
+                    </a:solidFill>
+                  </a:tcPr>
+                </a:tc>
+              </a:tr>
+              <a:tr h="530352">
+                <a:tc>
+                  <a:txBody>
+                    <a:bodyPr/>
+                    <a:lstStyle/>
+                    <a:p>
+                      <a:r>
+                        <a:rPr sz="1500" b="0">
+                          <a:solidFill>
+                            <a:srgbClr val="1A1A1A"/>
+                          </a:solidFill>
+                        </a:rPr>
+                        <a:t>J₂ (this work, 42 feat)</a:t>
+                      </a:r>
+                    </a:p>
+                  </a:txBody>
+                  <a:tcPr>
+                    <a:solidFill>
+                      <a:srgbClr val="FFFFFF"/>
+                    </a:solidFill>
+                  </a:tcPr>
+                </a:tc>
+                <a:tc>
+                  <a:txBody>
+                    <a:bodyPr/>
+                    <a:lstStyle/>
+                    <a:p>
+                      <a:r>
+                        <a:rPr sz="1500" b="0">
+                          <a:solidFill>
+                            <a:srgbClr val="1A1A1A"/>
+                          </a:solidFill>
+                        </a:rPr>
+                        <a:t>≤13 cr., 12,955</a:t>
+                      </a:r>
+                    </a:p>
+                  </a:txBody>
+                  <a:tcPr>
+                    <a:solidFill>
+                      <a:srgbClr val="FFFFFF"/>
+                    </a:solidFill>
+                  </a:tcPr>
+                </a:tc>
+                <a:tc>
+                  <a:txBody>
+                    <a:bodyPr/>
+                    <a:lstStyle/>
+                    <a:p>
+                      <a:r>
+                        <a:rPr sz="1500" b="1">
+                          <a:solidFill>
+                            <a:srgbClr val="1A1A1A"/>
+                          </a:solidFill>
+                        </a:rPr>
+                        <a:t>96.9%</a:t>
+                      </a:r>
+                    </a:p>
+                  </a:txBody>
+                  <a:tcPr>
+                    <a:solidFill>
+                      <a:srgbClr val="FFFFFF"/>
+                    </a:solidFill>
+                  </a:tcPr>
+                </a:tc>
+              </a:tr>
+              <a:tr h="530352">
+                <a:tc>
+                  <a:txBody>
+                    <a:bodyPr/>
+                    <a:lstStyle/>
+                    <a:p>
+                      <a:r>
+                        <a:rPr sz="1500" b="1">
+                          <a:solidFill>
+                            <a:srgbClr val="D55E00"/>
+                          </a:solidFill>
+                        </a:rPr>
+                        <a:t>J₂ + phase (this work)</a:t>
+                      </a:r>
+                    </a:p>
+                  </a:txBody>
+                  <a:tcPr>
+                    <a:solidFill>
+                      <a:srgbClr val="FBE7D8"/>
+                    </a:solidFill>
+                  </a:tcPr>
+                </a:tc>
+                <a:tc>
+                  <a:txBody>
+                    <a:bodyPr/>
+                    <a:lstStyle/>
+                    <a:p>
+                      <a:r>
+                        <a:rPr sz="1500" b="1">
+                          <a:solidFill>
+                            <a:srgbClr val="D55E00"/>
+                          </a:solidFill>
+                        </a:rPr>
+                        <a:t>≤13 cr., 12,955</a:t>
+                      </a:r>
+                    </a:p>
+                  </a:txBody>
+                  <a:tcPr>
+                    <a:solidFill>
+                      <a:srgbClr val="FBE7D8"/>
+                    </a:solidFill>
+                  </a:tcPr>
+                </a:tc>
+                <a:tc>
+                  <a:txBody>
+                    <a:bodyPr/>
+                    <a:lstStyle/>
+                    <a:p>
+                      <a:r>
+                        <a:rPr sz="1500" b="1">
+                          <a:solidFill>
+                            <a:srgbClr val="D55E00"/>
+                          </a:solidFill>
+                        </a:rPr>
+                        <a:t>97.3%</a:t>
+                      </a:r>
+                    </a:p>
+                  </a:txBody>
+                  <a:tcPr>
+                    <a:solidFill>
+                      <a:srgbClr val="FBE7D8"/>
+                    </a:solidFill>
+                  </a:tcPr>
+                </a:tc>
+              </a:tr>
+              <a:tr h="530352">
+                <a:tc>
+                  <a:txBody>
+                    <a:bodyPr/>
+                    <a:lstStyle/>
+                    <a:p>
+                      <a:r>
+                        <a:rPr sz="1500" b="0">
+                          <a:solidFill>
+                            <a:srgbClr val="1A1A1A"/>
+                          </a:solidFill>
+                        </a:rPr>
+                        <a:t>J₂ (Hughes et al. 2025)</a:t>
+                      </a:r>
+                    </a:p>
+                  </a:txBody>
+                  <a:tcPr>
+                    <a:solidFill>
+                      <a:srgbClr val="FFFFFF"/>
+                    </a:solidFill>
+                  </a:tcPr>
+                </a:tc>
+                <a:tc>
+                  <a:txBody>
+                    <a:bodyPr/>
+                    <a:lstStyle/>
+                    <a:p>
+                      <a:r>
+                        <a:rPr sz="1500" b="0">
+                          <a:solidFill>
+                            <a:srgbClr val="1A1A1A"/>
+                          </a:solidFill>
+                        </a:rPr>
+                        <a:t>≤16 cr., 1.7M</a:t>
+                      </a:r>
+                    </a:p>
+                  </a:txBody>
+                  <a:tcPr>
+                    <a:solidFill>
+                      <a:srgbClr val="FFFFFF"/>
+                    </a:solidFill>
+                  </a:tcPr>
+                </a:tc>
+                <a:tc>
+                  <a:txBody>
+                    <a:bodyPr/>
+                    <a:lstStyle/>
+                    <a:p>
+                      <a:r>
+                        <a:rPr sz="1500" b="1">
+                          <a:solidFill>
+                            <a:srgbClr val="1A1A1A"/>
+                          </a:solidFill>
+                        </a:rPr>
+                        <a:t>98.5% — best J₂</a:t>
+                      </a:r>
+                    </a:p>
+                  </a:txBody>
+                  <a:tcPr>
+                    <a:solidFill>
+                      <a:srgbClr val="FFFFFF"/>
+                    </a:solidFill>
+                  </a:tcPr>
+                </a:tc>
+              </a:tr>
+              <a:tr h="530352">
+                <a:tc>
+                  <a:txBody>
+                    <a:bodyPr/>
+                    <a:lstStyle/>
+                    <a:p>
+                      <a:r>
+                        <a:rPr sz="1500" b="0">
+                          <a:solidFill>
+                            <a:srgbClr val="1A1A1A"/>
+                          </a:solidFill>
+                        </a:rPr>
+                        <a:t>J₃ adjoint (Hughes et al.)</a:t>
+                      </a:r>
+                    </a:p>
+                  </a:txBody>
+                  <a:tcPr>
+                    <a:solidFill>
+                      <a:srgbClr val="FFFFFF"/>
+                    </a:solidFill>
+                  </a:tcPr>
+                </a:tc>
+                <a:tc>
+                  <a:txBody>
+                    <a:bodyPr/>
+                    <a:lstStyle/>
+                    <a:p>
+                      <a:r>
+                        <a:rPr sz="1500" b="0">
+                          <a:solidFill>
+                            <a:srgbClr val="1A1A1A"/>
+                          </a:solidFill>
+                        </a:rPr>
+                        <a:t>≤15 cr., 177k</a:t>
+                      </a:r>
+                    </a:p>
+                  </a:txBody>
+                  <a:tcPr>
+                    <a:solidFill>
+                      <a:srgbClr val="FFFFFF"/>
+                    </a:solidFill>
+                  </a:tcPr>
+                </a:tc>
+                <a:tc>
+                  <a:txBody>
+                    <a:bodyPr/>
+                    <a:lstStyle/>
+                    <a:p>
+                      <a:r>
+                        <a:rPr sz="1500" b="1">
+                          <a:solidFill>
+                            <a:srgbClr val="1A1A1A"/>
+                          </a:solidFill>
+                        </a:rPr>
+                        <a:t>99.3% — highest</a:t>
+                      </a:r>
+                    </a:p>
+                  </a:txBody>
+                  <a:tcPr>
+                    <a:solidFill>
+                      <a:srgbClr val="FFFFFF"/>
+                    </a:solidFill>
+                  </a:tcPr>
+                </a:tc>
+              </a:tr>
+            </a:tbl>
+          </a:graphicData>
+        </a:graphic>
+      </p:graphicFrame>
+      <p:sp>
+        <p:nvSpPr>
+          <p:cNvPr id="5" name="TextBox 4"/>
           <p:cNvSpPr txBox="1"/>
           <p:nvPr/>
         </p:nvSpPr>
         <p:spPr>
           <a:xfrm>
-            <a:off x="640080" y="1371600"/>
-            <a:ext cx="10972800" cy="5120640"/>
+            <a:off x="640080" y="4297680"/>
+            <a:ext cx="10972800" cy="2194560"/>
           </a:xfrm>
           <a:prstGeom prst="rect">
             <a:avLst/>
@@ -3329,17 +4102,17 @@
           <a:p>
             <a:pPr>
               <a:spcAft>
-                <a:spcPts val="1400"/>
+                <a:spcPts val="1200"/>
               </a:spcAft>
             </a:pPr>
             <a:r>
               <a:rPr b="1" sz="1900">
                 <a:solidFill>
-                  <a:srgbClr val="1A1A1A"/>
+                  <a:srgbClr val="D55E00"/>
                 </a:solidFill>
                 <a:latin typeface="Calibri"/>
               </a:rPr>
-              <a:t>Data.  </a:t>
+              <a:t>Takeaway.  </a:t>
             </a:r>
             <a:r>
               <a:rPr sz="1900">
@@ -3348,13 +4121,13 @@
                 </a:solidFill>
                 <a:latin typeface="Calibri"/>
               </a:rPr>
-              <a:t>New colored-Jones table: 1,426 knots ≤12 crossings with J₂ (fundamental) and J₃ (adjoint). Ground-truth volumes computed with SnapPy (ideal triangulation of the knot complement; exact by Mostow rigidity); 7 non-hyperbolic torus knots dropped → 1,419 knots.</a:t>
+              <a:t>A theory-motivated feature bought a real, budget-matched gain — for free, at every model size.</a:t>
             </a:r>
           </a:p>
           <a:p>
             <a:pPr>
               <a:spcAft>
-                <a:spcPts val="1400"/>
+                <a:spcPts val="1200"/>
               </a:spcAft>
             </a:pPr>
             <a:r>
@@ -3364,7 +4137,7 @@
                 </a:solidFill>
                 <a:latin typeface="Calibri"/>
               </a:rPr>
-              <a:t>Cleaning.  </a:t>
+              <a:t>Ceiling.  </a:t>
             </a:r>
             <a:r>
               <a:rPr sz="1900">
@@ -3373,23 +4146,23 @@
                 </a:solidFill>
                 <a:latin typeface="Calibri"/>
               </a:rPr>
-              <a:t>Mixed q/t variable conventions and framing-polluted exponent shifts → all features built on a shift-invariant canonical form. Validated: all 1,419 J₂ polynomials and volumes match the Part-I dataset.</a:t>
+              <a:t>But ~98.5% is set by the data: distinct knots share a J₂ yet differ ~3% in volume. No architecture resolves them.</a:t>
             </a:r>
           </a:p>
           <a:p>
             <a:pPr>
               <a:spcAft>
-                <a:spcPts val="1400"/>
+                <a:spcPts val="1200"/>
               </a:spcAft>
             </a:pPr>
             <a:r>
               <a:rPr b="1" sz="1900">
                 <a:solidFill>
-                  <a:srgbClr val="0072B2"/>
+                  <a:srgbClr val="1A1A1A"/>
                 </a:solidFill>
                 <a:latin typeface="Calibri"/>
               </a:rPr>
-              <a:t>Phases re-derived.  </a:t>
+              <a:t>Next.  </a:t>
             </a:r>
             <a:r>
               <a:rPr sz="1900">
@@ -3398,32 +4171,7 @@
                 </a:solidFill>
                 <a:latin typeface="Calibri"/>
               </a:rPr>
-              <a:t>The volume-correlated evaluation phase is swept per polynomial instead of assuming 3π/4 transfers: peaks at 13π/16 for J₂ (corr 0.943) and 5π/9 for J₃ (corr 0.959).</a:t>
-            </a:r>
-          </a:p>
-          <a:p>
-            <a:pPr>
-              <a:spcAft>
-                <a:spcPts val="1400"/>
-              </a:spcAft>
-            </a:pPr>
-            <a:r>
-              <a:rPr b="1" sz="1900">
-                <a:solidFill>
-                  <a:srgbClr val="D55E00"/>
-                </a:solidFill>
-                <a:latin typeface="Calibri"/>
-              </a:rPr>
-              <a:t>Design.  </a:t>
-            </a:r>
-            <a:r>
-              <a:rPr sz="1900">
-                <a:solidFill>
-                  <a:srgbClr val="1A1A1A"/>
-                </a:solidFill>
-                <a:latin typeface="Calibri"/>
-              </a:rPr>
-              <a:t>Three NSGA-II searches at the identical budget (pop 40 / gens 40 / 4+7 seeds / 500 epochs) on the same knots and split — J₂-only vs J₃-only vs J₂+J₃. Only the input polynomial differs.</a:t>
+              <a:t>Measured in Part II: on a matched 1,419-knot set, the adjoint J₃ more than halves the error of J₂ — the ceiling is real and J₃ breaks it.</a:t>
             </a:r>
           </a:p>
         </p:txBody>
@@ -3497,8 +4245,8 @@
         </p:nvSpPr>
         <p:spPr>
           <a:xfrm>
-            <a:off x="502920" y="256032"/>
-            <a:ext cx="11338560" cy="822960"/>
+            <a:off x="502920" y="274320"/>
+            <a:ext cx="11247120" cy="914400"/>
           </a:xfrm>
           <a:prstGeom prst="rect">
             <a:avLst/>
@@ -3517,51 +4265,27 @@
               </a:spcAft>
             </a:pPr>
             <a:r>
-              <a:rPr sz="2600" b="1" i="0">
+              <a:rPr sz="3000" b="1" i="0">
                 <a:solidFill>
                   <a:srgbClr val="1A1A1A"/>
                 </a:solidFill>
                 <a:latin typeface="Calibri"/>
               </a:rPr>
-              <a:t>The volume-tracking phase moves with the color</a:t>
-            </a:r>
-          </a:p>
-        </p:txBody>
-      </p:sp>
-      <p:pic>
-        <p:nvPicPr>
-          <p:cNvPr id="4" name="Picture 3" descr="phase_sweep_j2j3.png"/>
-          <p:cNvPicPr>
-            <a:picLocks noChangeAspect="1"/>
-          </p:cNvPicPr>
-          <p:nvPr/>
-        </p:nvPicPr>
-        <p:blipFill>
-          <a:blip r:embed="rId2"/>
-          <a:stretch>
-            <a:fillRect/>
-          </a:stretch>
-        </p:blipFill>
-        <p:spPr>
-          <a:xfrm>
-            <a:off x="2379701" y="1143000"/>
-            <a:ext cx="7432293" cy="4572000"/>
-          </a:xfrm>
-          <a:prstGeom prst="rect">
-            <a:avLst/>
-          </a:prstGeom>
-        </p:spPr>
-      </p:pic>
-      <p:sp>
-        <p:nvSpPr>
-          <p:cNvPr id="5" name="TextBox 4"/>
+              <a:t>Part II (measured): the adjoint J₃ on a colored-Jones dataset</a:t>
+            </a:r>
+          </a:p>
+        </p:txBody>
+      </p:sp>
+      <p:sp>
+        <p:nvSpPr>
+          <p:cNvPr id="4" name="TextBox 3"/>
           <p:cNvSpPr txBox="1"/>
           <p:nvPr/>
         </p:nvSpPr>
         <p:spPr>
           <a:xfrm>
-            <a:off x="640080" y="5989320"/>
-            <a:ext cx="10972800" cy="640080"/>
+            <a:off x="640080" y="1371600"/>
+            <a:ext cx="10972800" cy="5120640"/>
           </a:xfrm>
           <a:prstGeom prst="rect">
             <a:avLst/>
@@ -3574,19 +4298,103 @@
           </a:bodyPr>
           <a:lstStyle/>
           <a:p>
-            <a:pPr algn="ctr">
+            <a:pPr>
               <a:spcAft>
-                <a:spcPts val="800"/>
+                <a:spcPts val="1400"/>
               </a:spcAft>
             </a:pPr>
             <a:r>
-              <a:rPr sz="1600" b="1" i="0">
-                <a:solidFill>
-                  <a:srgbClr val="0072B2"/>
+              <a:rPr b="1" sz="1900">
+                <a:solidFill>
+                  <a:srgbClr val="1A1A1A"/>
                 </a:solidFill>
                 <a:latin typeface="Calibri"/>
               </a:rPr>
-              <a:t>corr(log|V(e^(iθ))|, log vol) peaks at θ = 13π/16 for J₂ (0.943) and 5π/9 for J₃ (0.959) — the literature's 3π/4 is not the peak here. J₃'s single scalar is the strongest signal yet.</a:t>
+              <a:t>Data.  </a:t>
+            </a:r>
+            <a:r>
+              <a:rPr sz="1900">
+                <a:solidFill>
+                  <a:srgbClr val="1A1A1A"/>
+                </a:solidFill>
+                <a:latin typeface="Calibri"/>
+              </a:rPr>
+              <a:t>New colored-Jones table: 1,426 knots ≤12 crossings with J₂ (fundamental) and J₃ (adjoint). Ground-truth volumes computed with SnapPy (ideal triangulation of the knot complement; exact by Mostow rigidity); 7 non-hyperbolic torus knots dropped → 1,419 knots.</a:t>
+            </a:r>
+          </a:p>
+          <a:p>
+            <a:pPr>
+              <a:spcAft>
+                <a:spcPts val="1400"/>
+              </a:spcAft>
+            </a:pPr>
+            <a:r>
+              <a:rPr b="1" sz="1900">
+                <a:solidFill>
+                  <a:srgbClr val="1A1A1A"/>
+                </a:solidFill>
+                <a:latin typeface="Calibri"/>
+              </a:rPr>
+              <a:t>Cleaning.  </a:t>
+            </a:r>
+            <a:r>
+              <a:rPr sz="1900">
+                <a:solidFill>
+                  <a:srgbClr val="1A1A1A"/>
+                </a:solidFill>
+                <a:latin typeface="Calibri"/>
+              </a:rPr>
+              <a:t>Mixed q/t variable conventions and framing-polluted exponent shifts → all features built on a shift-invariant canonical form. Validated: all 1,419 J₂ polynomials and volumes match the Part-I dataset.</a:t>
+            </a:r>
+          </a:p>
+          <a:p>
+            <a:pPr>
+              <a:spcAft>
+                <a:spcPts val="1400"/>
+              </a:spcAft>
+            </a:pPr>
+            <a:r>
+              <a:rPr b="1" sz="1900">
+                <a:solidFill>
+                  <a:srgbClr val="0072B2"/>
+                </a:solidFill>
+                <a:latin typeface="Calibri"/>
+              </a:rPr>
+              <a:t>Phases re-derived.  </a:t>
+            </a:r>
+            <a:r>
+              <a:rPr sz="1900">
+                <a:solidFill>
+                  <a:srgbClr val="1A1A1A"/>
+                </a:solidFill>
+                <a:latin typeface="Calibri"/>
+              </a:rPr>
+              <a:t>The volume-correlated evaluation phase is swept per polynomial instead of assuming 3π/4 transfers: peaks at 13π/16 for J₂ (corr 0.943) and 5π/9 for J₃ (corr 0.959).</a:t>
+            </a:r>
+          </a:p>
+          <a:p>
+            <a:pPr>
+              <a:spcAft>
+                <a:spcPts val="1400"/>
+              </a:spcAft>
+            </a:pPr>
+            <a:r>
+              <a:rPr b="1" sz="1900">
+                <a:solidFill>
+                  <a:srgbClr val="D55E00"/>
+                </a:solidFill>
+                <a:latin typeface="Calibri"/>
+              </a:rPr>
+              <a:t>Design.  </a:t>
+            </a:r>
+            <a:r>
+              <a:rPr sz="1900">
+                <a:solidFill>
+                  <a:srgbClr val="1A1A1A"/>
+                </a:solidFill>
+                <a:latin typeface="Calibri"/>
+              </a:rPr>
+              <a:t>Three NSGA-II searches at the identical budget (pop 40 / gens 40 / 4+7 seeds / 500 epochs) on the same knots and split — J₂-only vs J₃-only vs J₂+J₃. Only the input polynomial differs.</a:t>
             </a:r>
           </a:p>
         </p:txBody>
@@ -3624,7 +4432,7 @@
             <a:avLst/>
           </a:prstGeom>
           <a:solidFill>
-            <a:srgbClr val="D55E00"/>
+            <a:srgbClr val="0072B2"/>
           </a:solidFill>
           <a:ln>
             <a:noFill/>
@@ -3686,14 +4494,14 @@
                 </a:solidFill>
                 <a:latin typeface="Calibri"/>
               </a:rPr>
-              <a:t>J₃ breaks the J₂ ceiling — measured, matched budget</a:t>
+              <a:t>The volume-tracking phase moves with the color</a:t>
             </a:r>
           </a:p>
         </p:txBody>
       </p:sp>
       <p:pic>
         <p:nvPicPr>
-          <p:cNvPr id="4" name="Picture 3" descr="j2j3_accuracy.png"/>
+          <p:cNvPr id="4" name="Picture 3" descr="phase_sweep_j2j3.png"/>
           <p:cNvPicPr>
             <a:picLocks noChangeAspect="1"/>
           </p:cNvPicPr>
@@ -3707,8 +4515,8 @@
         </p:blipFill>
         <p:spPr>
           <a:xfrm>
-            <a:off x="2980836" y="1143000"/>
-            <a:ext cx="6230023" cy="4572000"/>
+            <a:off x="2379701" y="1143000"/>
+            <a:ext cx="7432293" cy="4572000"/>
           </a:xfrm>
           <a:prstGeom prst="rect">
             <a:avLst/>
@@ -3745,11 +4553,11 @@
             <a:r>
               <a:rPr sz="1600" b="1" i="0">
                 <a:solidFill>
-                  <a:srgbClr val="D55E00"/>
+                  <a:srgbClr val="0072B2"/>
                 </a:solidFill>
                 <a:latin typeface="Calibri"/>
               </a:rPr>
-              <a:t>Identical knots, split, and search budget: J₂ 94.84% → J₃ 97.67% → J₂+J₃ 97.92% ensemble accuracy. J₃ alone cuts the error of J₂ by 2.2×; every knee stays under 2.7k params.</a:t>
+              <a:t>corr(log|V(e^(iθ))|, log vol) peaks at θ = 13π/16 for J₂ (0.943) and 5π/9 for J₃ (0.959) — the literature's 3π/4 is not the peak here. J₃'s single scalar is the strongest signal yet.</a:t>
             </a:r>
           </a:p>
         </p:txBody>
@@ -3787,7 +4595,7 @@
             <a:avLst/>
           </a:prstGeom>
           <a:solidFill>
-            <a:srgbClr val="0072B2"/>
+            <a:srgbClr val="D55E00"/>
           </a:solidFill>
           <a:ln>
             <a:noFill/>
@@ -3849,14 +4657,14 @@
                 </a:solidFill>
                 <a:latin typeface="Calibri"/>
               </a:rPr>
-              <a:t>The best J₂+J₃ model: the Pareto-knee architecture</a:t>
+              <a:t>J₃ breaks the J₂ ceiling — measured, matched budget</a:t>
             </a:r>
           </a:p>
         </p:txBody>
       </p:sp>
       <p:pic>
         <p:nvPicPr>
-          <p:cNvPr id="4" name="Picture 3" descr="architecture_j2j3.png"/>
+          <p:cNvPr id="4" name="Picture 3" descr="j2j3_accuracy.png"/>
           <p:cNvPicPr>
             <a:picLocks noChangeAspect="1"/>
           </p:cNvPicPr>
@@ -3870,8 +4678,8 @@
         </p:blipFill>
         <p:spPr>
           <a:xfrm>
-            <a:off x="792327" y="1143000"/>
-            <a:ext cx="10607040" cy="4209370"/>
+            <a:off x="2980836" y="1143000"/>
+            <a:ext cx="6230023" cy="4572000"/>
           </a:xfrm>
           <a:prstGeom prst="rect">
             <a:avLst/>
@@ -3908,11 +4716,11 @@
             <a:r>
               <a:rPr sz="1600" b="1" i="0">
                 <a:solidFill>
-                  <a:srgbClr val="0072B2"/>
+                  <a:srgbClr val="D55E00"/>
                 </a:solidFill>
                 <a:latin typeface="Calibri"/>
               </a:rPr>
-              <a:t>Found by the joined search: 68→27→27→1 GELU MLP, 2,647 params (lr 5.5e-3, dropout 0.007, L2 2.0e-6, batch 128) — test MRE 0.0246 ± 0.0013, ensemble 0.0208 (97.92%). Weights: results_j2j3_j2j3/knee_model.pt.</a:t>
+              <a:t>Identical knots, split, and search budget: J₂ 94.84% → J₃ 97.67% → J₂+J₃ 97.92% ensemble accuracy. J₃ alone cuts the error of J₂ by 2.2×; every knee stays under 2.7k params.</a:t>
             </a:r>
           </a:p>
         </p:txBody>
@@ -3950,7 +4758,7 @@
             <a:avLst/>
           </a:prstGeom>
           <a:solidFill>
-            <a:srgbClr val="D55E00"/>
+            <a:srgbClr val="0072B2"/>
           </a:solidFill>
           <a:ln>
             <a:noFill/>
@@ -4012,6 +4820,169 @@
                 </a:solidFill>
                 <a:latin typeface="Calibri"/>
               </a:rPr>
+              <a:t>The best J₂+J₃ model: the Pareto-knee architecture</a:t>
+            </a:r>
+          </a:p>
+        </p:txBody>
+      </p:sp>
+      <p:pic>
+        <p:nvPicPr>
+          <p:cNvPr id="4" name="Picture 3" descr="architecture_j2j3.png"/>
+          <p:cNvPicPr>
+            <a:picLocks noChangeAspect="1"/>
+          </p:cNvPicPr>
+          <p:nvPr/>
+        </p:nvPicPr>
+        <p:blipFill>
+          <a:blip r:embed="rId2"/>
+          <a:stretch>
+            <a:fillRect/>
+          </a:stretch>
+        </p:blipFill>
+        <p:spPr>
+          <a:xfrm>
+            <a:off x="792327" y="1143000"/>
+            <a:ext cx="10607040" cy="4209370"/>
+          </a:xfrm>
+          <a:prstGeom prst="rect">
+            <a:avLst/>
+          </a:prstGeom>
+        </p:spPr>
+      </p:pic>
+      <p:sp>
+        <p:nvSpPr>
+          <p:cNvPr id="5" name="TextBox 4"/>
+          <p:cNvSpPr txBox="1"/>
+          <p:nvPr/>
+        </p:nvSpPr>
+        <p:spPr>
+          <a:xfrm>
+            <a:off x="640080" y="5989320"/>
+            <a:ext cx="10972800" cy="640080"/>
+          </a:xfrm>
+          <a:prstGeom prst="rect">
+            <a:avLst/>
+          </a:prstGeom>
+          <a:noFill/>
+        </p:spPr>
+        <p:txBody>
+          <a:bodyPr wrap="square">
+            <a:spAutoFit/>
+          </a:bodyPr>
+          <a:lstStyle/>
+          <a:p>
+            <a:pPr algn="ctr">
+              <a:spcAft>
+                <a:spcPts val="800"/>
+              </a:spcAft>
+            </a:pPr>
+            <a:r>
+              <a:rPr sz="1600" b="1" i="0">
+                <a:solidFill>
+                  <a:srgbClr val="0072B2"/>
+                </a:solidFill>
+                <a:latin typeface="Calibri"/>
+              </a:rPr>
+              <a:t>Found by the joined search: 68→27→27→1 GELU MLP, 2,647 params (lr 5.5e-3, dropout 0.007, L2 2.0e-6, batch 128) — test MRE 0.0246 ± 0.0013, ensemble 0.0208 (97.92%). Weights: results_j2j3_j2j3/knee_model.pt.</a:t>
+            </a:r>
+          </a:p>
+        </p:txBody>
+      </p:sp>
+    </p:spTree>
+  </p:cSld>
+  <p:clrMapOvr>
+    <a:masterClrMapping/>
+  </p:clrMapOvr>
+</p:sld>
+</file>
+
+<file path=ppt/slides/slide15.xml><?xml version="1.0" encoding="utf-8"?>
+<p:sld xmlns:a="http://schemas.openxmlformats.org/drawingml/2006/main" xmlns:p="http://schemas.openxmlformats.org/presentationml/2006/main" xmlns:r="http://schemas.openxmlformats.org/officeDocument/2006/relationships">
+  <p:cSld>
+    <p:spTree>
+      <p:nvGrpSpPr>
+        <p:cNvPr id="1" name=""/>
+        <p:cNvGrpSpPr/>
+        <p:nvPr/>
+      </p:nvGrpSpPr>
+      <p:grpSpPr/>
+      <p:sp>
+        <p:nvSpPr>
+          <p:cNvPr id="2" name="Rectangle 1"/>
+          <p:cNvSpPr/>
+          <p:nvPr/>
+        </p:nvSpPr>
+        <p:spPr>
+          <a:xfrm>
+            <a:off x="0" y="0"/>
+            <a:ext cx="164592" cy="6858000"/>
+          </a:xfrm>
+          <a:prstGeom prst="rect">
+            <a:avLst/>
+          </a:prstGeom>
+          <a:solidFill>
+            <a:srgbClr val="D55E00"/>
+          </a:solidFill>
+          <a:ln>
+            <a:noFill/>
+          </a:ln>
+        </p:spPr>
+        <p:style>
+          <a:lnRef idx="1">
+            <a:schemeClr val="accent1"/>
+          </a:lnRef>
+          <a:fillRef idx="3">
+            <a:schemeClr val="accent1"/>
+          </a:fillRef>
+          <a:effectRef idx="2">
+            <a:schemeClr val="accent1"/>
+          </a:effectRef>
+          <a:fontRef idx="minor">
+            <a:schemeClr val="lt1"/>
+          </a:fontRef>
+        </p:style>
+        <p:txBody>
+          <a:bodyPr rtlCol="0" anchor="ctr"/>
+          <a:lstStyle/>
+          <a:p>
+            <a:pPr algn="ctr"/>
+          </a:p>
+        </p:txBody>
+      </p:sp>
+      <p:sp>
+        <p:nvSpPr>
+          <p:cNvPr id="3" name="TextBox 2"/>
+          <p:cNvSpPr txBox="1"/>
+          <p:nvPr/>
+        </p:nvSpPr>
+        <p:spPr>
+          <a:xfrm>
+            <a:off x="502920" y="256032"/>
+            <a:ext cx="11338560" cy="822960"/>
+          </a:xfrm>
+          <a:prstGeom prst="rect">
+            <a:avLst/>
+          </a:prstGeom>
+          <a:noFill/>
+        </p:spPr>
+        <p:txBody>
+          <a:bodyPr wrap="square">
+            <a:spAutoFit/>
+          </a:bodyPr>
+          <a:lstStyle/>
+          <a:p>
+            <a:pPr algn="l">
+              <a:spcAft>
+                <a:spcPts val="800"/>
+              </a:spcAft>
+            </a:pPr>
+            <a:r>
+              <a:rPr sz="2600" b="1" i="0">
+                <a:solidFill>
+                  <a:srgbClr val="1A1A1A"/>
+                </a:solidFill>
+                <a:latin typeface="Calibri"/>
+              </a:rPr>
               <a:t>Control (measured): the J₂+J₃ gain rides on the phase columns</a:t>
             </a:r>
           </a:p>
@@ -4088,7 +5059,7 @@
 </p:sld>
 </file>
 
-<file path=ppt/slides/slide15.xml><?xml version="1.0" encoding="utf-8"?>
+<file path=ppt/slides/slide16.xml><?xml version="1.0" encoding="utf-8"?>
 <p:sld xmlns:a="http://schemas.openxmlformats.org/drawingml/2006/main" xmlns:p="http://schemas.openxmlformats.org/presentationml/2006/main" xmlns:r="http://schemas.openxmlformats.org/officeDocument/2006/relationships">
   <p:cSld>
     <p:spTree>
@@ -5360,7 +6331,7 @@
 </p:sld>
 </file>
 
-<file path=ppt/slides/slide16.xml><?xml version="1.0" encoding="utf-8"?>
+<file path=ppt/slides/slide17.xml><?xml version="1.0" encoding="utf-8"?>
 <p:sld xmlns:a="http://schemas.openxmlformats.org/drawingml/2006/main" xmlns:p="http://schemas.openxmlformats.org/presentationml/2006/main" xmlns:r="http://schemas.openxmlformats.org/officeDocument/2006/relationships">
   <p:cSld>
     <p:spTree>
@@ -5570,7 +6541,7 @@
                 </a:solidFill>
                 <a:latin typeface="Calibri"/>
               </a:rPr>
-              <a:t>Scale J₃ to the ≤13-crossing census (12,955 knots) to close the data gap toward the published 99.3%; sweep phases for higher colors J₄, J₅…; interpret the knee networks symbolically.</a:t>
+              <a:t>Scale J₃ to the ≤13-crossing census (12,955 knots) to close the data gap toward the published 99.3%; push the substitution one level higher — predict the volume-correlated behavior of J₄, J₅, … directly from cheap low-color data, avoiding their computation entirely; interpret the knee networks symbolically.</a:t>
             </a:r>
           </a:p>
         </p:txBody>
@@ -5867,8 +6838,8 @@
         </p:nvSpPr>
         <p:spPr>
           <a:xfrm>
-            <a:off x="502920" y="256032"/>
-            <a:ext cx="11338560" cy="822960"/>
+            <a:off x="502920" y="274320"/>
+            <a:ext cx="11247120" cy="914400"/>
           </a:xfrm>
           <a:prstGeom prst="rect">
             <a:avLst/>
@@ -5887,51 +6858,27 @@
               </a:spcAft>
             </a:pPr>
             <a:r>
-              <a:rPr sz="2600" b="1" i="0">
+              <a:rPr sz="3000" b="1" i="0">
                 <a:solidFill>
                   <a:srgbClr val="1A1A1A"/>
                 </a:solidFill>
                 <a:latin typeface="Calibri"/>
               </a:rPr>
-              <a:t>A single phase evaluation nearly tracks the volume</a:t>
-            </a:r>
-          </a:p>
-        </p:txBody>
-      </p:sp>
-      <p:pic>
-        <p:nvPicPr>
-          <p:cNvPr id="4" name="Picture 3" descr="feature_correlation.png"/>
-          <p:cNvPicPr>
-            <a:picLocks noChangeAspect="1"/>
-          </p:cNvPicPr>
-          <p:nvPr/>
-        </p:nvPicPr>
-        <p:blipFill>
-          <a:blip r:embed="rId2"/>
-          <a:stretch>
-            <a:fillRect/>
-          </a:stretch>
-        </p:blipFill>
-        <p:spPr>
-          <a:xfrm>
-            <a:off x="792327" y="1143000"/>
-            <a:ext cx="10607040" cy="4499522"/>
-          </a:xfrm>
-          <a:prstGeom prst="rect">
-            <a:avLst/>
-          </a:prstGeom>
-        </p:spPr>
-      </p:pic>
-      <p:sp>
-        <p:nvSpPr>
-          <p:cNvPr id="5" name="TextBox 4"/>
+              <a:t>Why learn it: a cheap stand-in for an intractable limit</a:t>
+            </a:r>
+          </a:p>
+        </p:txBody>
+      </p:sp>
+      <p:sp>
+        <p:nvSpPr>
+          <p:cNvPr id="4" name="TextBox 3"/>
           <p:cNvSpPr txBox="1"/>
           <p:nvPr/>
         </p:nvSpPr>
         <p:spPr>
           <a:xfrm>
-            <a:off x="640080" y="5989320"/>
-            <a:ext cx="10972800" cy="640080"/>
+            <a:off x="640080" y="1371600"/>
+            <a:ext cx="10972800" cy="5120640"/>
           </a:xfrm>
           <a:prstGeom prst="rect">
             <a:avLst/>
@@ -5944,19 +6891,103 @@
           </a:bodyPr>
           <a:lstStyle/>
           <a:p>
-            <a:pPr algn="ctr">
+            <a:pPr>
               <a:spcAft>
-                <a:spcPts val="800"/>
+                <a:spcPts val="1400"/>
               </a:spcAft>
             </a:pPr>
             <a:r>
-              <a:rPr sz="1600" b="1" i="0">
-                <a:solidFill>
-                  <a:srgbClr val="D55E00"/>
+              <a:rPr b="1" sz="1900">
+                <a:solidFill>
+                  <a:srgbClr val="1A1A1A"/>
                 </a:solidFill>
                 <a:latin typeface="Calibri"/>
               </a:rPr>
-              <a:t>|V(e^(3πi/4))| is the strongest single predictor in the set (r = 0.93 vs 0.80 for the previous best) — before any network.</a:t>
+              <a:t>The catch.  </a:t>
+            </a:r>
+            <a:r>
+              <a:rPr sz="1900">
+                <a:solidFill>
+                  <a:srgbClr val="1A1A1A"/>
+                </a:solidFill>
+                <a:latin typeface="Calibri"/>
+              </a:rPr>
+              <a:t>The volume conjecture's actual claim only holds in the limit of infinitely high color N → ∞. Low color (J₂, J₂+J₃) is cheap to compute; that limit is computationally intractable to reach directly.</a:t>
+            </a:r>
+          </a:p>
+          <a:p>
+            <a:pPr>
+              <a:spcAft>
+                <a:spcPts val="1400"/>
+              </a:spcAft>
+            </a:pPr>
+            <a:r>
+              <a:rPr b="1" sz="1900">
+                <a:solidFill>
+                  <a:srgbClr val="D55E00"/>
+                </a:solidFill>
+                <a:latin typeface="Calibri"/>
+              </a:rPr>
+              <a:t>The substitution.  </a:t>
+            </a:r>
+            <a:r>
+              <a:rPr sz="1900">
+                <a:solidFill>
+                  <a:srgbClr val="1A1A1A"/>
+                </a:solidFill>
+                <a:latin typeface="Calibri"/>
+              </a:rPr>
+              <a:t>Instead of chasing the limit, train on cheap low-color data paired with independently computed ground-truth volumes (SnapPy). The network learns, empirically, whatever relationship links the low-level polynomial coefficients to the high-level geometry.</a:t>
+            </a:r>
+          </a:p>
+          <a:p>
+            <a:pPr>
+              <a:spcAft>
+                <a:spcPts val="1400"/>
+              </a:spcAft>
+            </a:pPr>
+            <a:r>
+              <a:rPr b="1" sz="1900">
+                <a:solidFill>
+                  <a:srgbClr val="1A1A1A"/>
+                </a:solidFill>
+                <a:latin typeface="Calibri"/>
+              </a:rPr>
+              <a:t>What you get.  </a:t>
+            </a:r>
+            <a:r>
+              <a:rPr sz="1900">
+                <a:solidFill>
+                  <a:srgbClr val="1A1A1A"/>
+                </a:solidFill>
+                <a:latin typeface="Calibri"/>
+              </a:rPr>
+              <a:t>Learned pattern-recognition replaces the intractable exact computation: a single forward pass at inference extracts what would otherwise require an infeasible high-color limit — cheap at the low level, exploiting structure that only becomes meaningful at the higher level.</a:t>
+            </a:r>
+          </a:p>
+          <a:p>
+            <a:pPr>
+              <a:spcAft>
+                <a:spcPts val="1400"/>
+              </a:spcAft>
+            </a:pPr>
+            <a:r>
+              <a:rPr b="1" sz="1900">
+                <a:solidFill>
+                  <a:srgbClr val="0072B2"/>
+                </a:solidFill>
+                <a:latin typeface="Calibri"/>
+              </a:rPr>
+              <a:t>One level higher.  </a:t>
+            </a:r>
+            <a:r>
+              <a:rPr sz="1900">
+                <a:solidFill>
+                  <a:srgbClr val="1A1A1A"/>
+                </a:solidFill>
+                <a:latin typeface="Calibri"/>
+              </a:rPr>
+              <a:t>Extension: predict the volume-correlated behavior of higher-color polynomials (J₄, J₅, …) directly from low-color data — avoiding their computation entirely, not merely the infinite-N limit.</a:t>
             </a:r>
           </a:p>
         </p:txBody>
@@ -6056,14 +7087,14 @@
                 </a:solidFill>
                 <a:latin typeface="Calibri"/>
               </a:rPr>
-              <a:t>Theory put the feature exactly where the signal peaks</a:t>
+              <a:t>A single phase evaluation nearly tracks the volume</a:t>
             </a:r>
           </a:p>
         </p:txBody>
       </p:sp>
       <p:pic>
         <p:nvPicPr>
-          <p:cNvPr id="4" name="Picture 3" descr="phase_sweep.png"/>
+          <p:cNvPr id="4" name="Picture 3" descr="feature_correlation.png"/>
           <p:cNvPicPr>
             <a:picLocks noChangeAspect="1"/>
           </p:cNvPicPr>
@@ -6077,8 +7108,8 @@
         </p:blipFill>
         <p:spPr>
           <a:xfrm>
-            <a:off x="2379701" y="1143000"/>
-            <a:ext cx="7432293" cy="4572000"/>
+            <a:off x="792327" y="1143000"/>
+            <a:ext cx="10607040" cy="4499522"/>
           </a:xfrm>
           <a:prstGeom prst="rect">
             <a:avLst/>
@@ -6119,7 +7150,7 @@
                 </a:solidFill>
                 <a:latin typeface="Calibri"/>
               </a:rPr>
-              <a:t>Single-scalar correlation with volume is ≈ 0 at most evaluation angles and peaks right at q₀ = e^(3πi/4) (empirical max at 0.78π). The phase isn't tuned — the volume conjecture pointed to it.</a:t>
+              <a:t>|V(e^(3πi/4))| is the strongest single predictor in the set (r = 0.93 vs 0.80 for the previous best) — before any network.</a:t>
             </a:r>
           </a:p>
         </p:txBody>
@@ -6219,14 +7250,14 @@
                 </a:solidFill>
                 <a:latin typeface="Calibri"/>
               </a:rPr>
-              <a:t>Result: same search budget, one added feature</a:t>
+              <a:t>Theory put the feature exactly where the signal peaks</a:t>
             </a:r>
           </a:p>
         </p:txBody>
       </p:sp>
       <p:pic>
         <p:nvPicPr>
-          <p:cNvPr id="4" name="Picture 3" descr="ab_accuracy.png"/>
+          <p:cNvPr id="4" name="Picture 3" descr="phase_sweep.png"/>
           <p:cNvPicPr>
             <a:picLocks noChangeAspect="1"/>
           </p:cNvPicPr>
@@ -6240,8 +7271,8 @@
         </p:blipFill>
         <p:spPr>
           <a:xfrm>
-            <a:off x="3312440" y="1143000"/>
-            <a:ext cx="5566814" cy="4572000"/>
+            <a:off x="2379701" y="1143000"/>
+            <a:ext cx="7432293" cy="4572000"/>
           </a:xfrm>
           <a:prstGeom prst="rect">
             <a:avLst/>
@@ -6282,7 +7313,7 @@
                 </a:solidFill>
                 <a:latin typeface="Calibri"/>
               </a:rPr>
-              <a:t>Ensemble test accuracy 97.14% → 97.31%; mean 96.93% → 97.11% (≈ 6% relative error reduction, ~3σ).</a:t>
+              <a:t>Single-scalar correlation with volume is ≈ 0 at most evaluation angles and peaks right at q₀ = e^(3πi/4) (empirical max at 0.78π). The phase isn't tuned — the volume conjecture pointed to it.</a:t>
             </a:r>
           </a:p>
         </p:txBody>
@@ -6382,14 +7413,14 @@
                 </a:solidFill>
                 <a:latin typeface="Calibri"/>
               </a:rPr>
-              <a:t>Control (measured): the gain is the phase, not just 3 more inputs</a:t>
+              <a:t>Result: same search budget, one added feature</a:t>
             </a:r>
           </a:p>
         </p:txBody>
       </p:sp>
       <p:pic>
         <p:nvPicPr>
-          <p:cNvPr id="4" name="Picture 3" descr="ab_ablation.png"/>
+          <p:cNvPr id="4" name="Picture 3" descr="ab_accuracy.png"/>
           <p:cNvPicPr>
             <a:picLocks noChangeAspect="1"/>
           </p:cNvPicPr>
@@ -6403,8 +7434,8 @@
         </p:blipFill>
         <p:spPr>
           <a:xfrm>
-            <a:off x="2955965" y="1143000"/>
-            <a:ext cx="6279764" cy="4572000"/>
+            <a:off x="3312440" y="1143000"/>
+            <a:ext cx="5566814" cy="4572000"/>
           </a:xfrm>
           <a:prstGeom prst="rect">
             <a:avLst/>
@@ -6445,7 +7476,7 @@
                 </a:solidFill>
                 <a:latin typeface="Calibri"/>
               </a:rPr>
-              <a:t>Same knee net [32,18,54,18], only the 3 extra columns vary: phase 97.31% &gt; zeroed (J₂-only) 97.22% &gt; Gaussian noise 97.11% ensemble. The improvement is the volume signal — noise columns even hurt slightly.</a:t>
+              <a:t>Ensemble test accuracy 97.14% → 97.31%; mean 96.93% → 97.11% (≈ 6% relative error reduction, ~3σ).</a:t>
             </a:r>
           </a:p>
         </p:txBody>
@@ -6545,14 +7576,14 @@
                 </a:solidFill>
                 <a:latin typeface="Calibri"/>
               </a:rPr>
-              <a:t>The whole Pareto front shifts down — but stays flat</a:t>
+              <a:t>Control (measured): the gain is the phase, not just 3 more inputs</a:t>
             </a:r>
           </a:p>
         </p:txBody>
       </p:sp>
       <p:pic>
         <p:nvPicPr>
-          <p:cNvPr id="4" name="Picture 3" descr="pareto_overlay.png"/>
+          <p:cNvPr id="4" name="Picture 3" descr="ab_ablation.png"/>
           <p:cNvPicPr>
             <a:picLocks noChangeAspect="1"/>
           </p:cNvPicPr>
@@ -6566,8 +7597,8 @@
         </p:blipFill>
         <p:spPr>
           <a:xfrm>
-            <a:off x="2519537" y="1143000"/>
-            <a:ext cx="7152620" cy="4572000"/>
+            <a:off x="2955965" y="1143000"/>
+            <a:ext cx="6279764" cy="4572000"/>
           </a:xfrm>
           <a:prstGeom prst="rect">
             <a:avLst/>
@@ -6608,7 +7639,7 @@
                 </a:solidFill>
                 <a:latin typeface="Calibri"/>
               </a:rPr>
-              <a:t>Lower error everywhere; ~180× more parameters barely helps. The bottleneck is the J₂ signal, not the model.</a:t>
+              <a:t>Same knee net [32,18,54,18], only the 3 extra columns vary: phase 97.31% &gt; zeroed (J₂-only) 97.22% &gt; Gaussian noise 97.11% ensemble. The improvement is the volume signal — noise columns even hurt slightly.</a:t>
             </a:r>
           </a:p>
         </p:txBody>
@@ -6646,7 +7677,7 @@
             <a:avLst/>
           </a:prstGeom>
           <a:solidFill>
-            <a:srgbClr val="0072B2"/>
+            <a:srgbClr val="D55E00"/>
           </a:solidFill>
           <a:ln>
             <a:noFill/>
@@ -6708,14 +7739,14 @@
                 </a:solidFill>
                 <a:latin typeface="Calibri"/>
               </a:rPr>
-              <a:t>The best model: the phase-run's Pareto-knee architecture</a:t>
+              <a:t>The whole Pareto front shifts down — but stays flat</a:t>
             </a:r>
           </a:p>
         </p:txBody>
       </p:sp>
       <p:pic>
         <p:nvPicPr>
-          <p:cNvPr id="4" name="Picture 3" descr="architecture.png"/>
+          <p:cNvPr id="4" name="Picture 3" descr="pareto_overlay.png"/>
           <p:cNvPicPr>
             <a:picLocks noChangeAspect="1"/>
           </p:cNvPicPr>
@@ -6729,8 +7760,8 @@
         </p:blipFill>
         <p:spPr>
           <a:xfrm>
-            <a:off x="792327" y="1143000"/>
-            <a:ext cx="10607040" cy="4209370"/>
+            <a:off x="2519537" y="1143000"/>
+            <a:ext cx="7152620" cy="4572000"/>
           </a:xfrm>
           <a:prstGeom prst="rect">
             <a:avLst/>
@@ -6767,11 +7798,11 @@
             <a:r>
               <a:rPr sz="1600" b="1" i="0">
                 <a:solidFill>
-                  <a:srgbClr val="0072B2"/>
+                  <a:srgbClr val="D55E00"/>
                 </a:solidFill>
                 <a:latin typeface="Calibri"/>
               </a:rPr>
-              <a:t>Found by the 45-feature (phase) search: 45→32→18→54→18→1 GELU MLP, 4,101 params (lr 6.4e-3, dropout 0.006, L2 1e-6, batch 256) — test MRE 0.0289 ± 0.0004, ensemble 0.0269 (97.31%). Tiny, because the phase feature hands even a small net a near-direct line to the volume.</a:t>
+              <a:t>Lower error everywhere; ~180× more parameters barely helps. The bottleneck is the J₂ signal, not the model.</a:t>
             </a:r>
           </a:p>
         </p:txBody>
@@ -6809,7 +7840,7 @@
             <a:avLst/>
           </a:prstGeom>
           <a:solidFill>
-            <a:srgbClr val="D55E00"/>
+            <a:srgbClr val="0072B2"/>
           </a:solidFill>
           <a:ln>
             <a:noFill/>
@@ -6845,8 +7876,8 @@
         </p:nvSpPr>
         <p:spPr>
           <a:xfrm>
-            <a:off x="502920" y="274320"/>
-            <a:ext cx="11247120" cy="914400"/>
+            <a:off x="502920" y="256032"/>
+            <a:ext cx="11338560" cy="822960"/>
           </a:xfrm>
           <a:prstGeom prst="rect">
             <a:avLst/>
@@ -6865,369 +7896,41 @@
               </a:spcAft>
             </a:pPr>
             <a:r>
-              <a:rPr sz="3000" b="1" i="0">
+              <a:rPr sz="2600" b="1" i="0">
                 <a:solidFill>
                   <a:srgbClr val="1A1A1A"/>
                 </a:solidFill>
                 <a:latin typeface="Calibri"/>
               </a:rPr>
-              <a:t>An information ceiling — and how to break it</a:t>
-            </a:r>
-          </a:p>
-        </p:txBody>
-      </p:sp>
-      <p:graphicFrame>
-        <p:nvGraphicFramePr>
-          <p:cNvPr id="4" name="Table 3"/>
-          <p:cNvGraphicFramePr>
-            <a:graphicFrameLocks noGrp="1"/>
-          </p:cNvGraphicFramePr>
+              <a:t>The best model: the phase-run's Pareto-knee architecture</a:t>
+            </a:r>
+          </a:p>
+        </p:txBody>
+      </p:sp>
+      <p:pic>
+        <p:nvPicPr>
+          <p:cNvPr id="4" name="Picture 3" descr="architecture.png"/>
+          <p:cNvPicPr>
+            <a:picLocks noChangeAspect="1"/>
+          </p:cNvPicPr>
           <p:nvPr/>
-        </p:nvGraphicFramePr>
-        <p:xfrm>
-          <a:off x="777240" y="1371600"/>
-          <a:ext cx="10607040" cy="2651760"/>
-        </p:xfrm>
-        <a:graphic>
-          <a:graphicData uri="http://schemas.openxmlformats.org/drawingml/2006/table">
-            <a:tbl>
-              <a:tblPr firstRow="1" bandRow="1">
-                <a:tableStyleId>{5C22544A-7EE6-4342-B048-85BDC9FD1C3A}</a:tableStyleId>
-              </a:tblPr>
-              <a:tblGrid>
-                <a:gridCol w="4206240"/>
-                <a:gridCol w="3291840"/>
-                <a:gridCol w="3108960"/>
-              </a:tblGrid>
-              <a:tr h="530352">
-                <a:tc>
-                  <a:txBody>
-                    <a:bodyPr/>
-                    <a:lstStyle/>
-                    <a:p>
-                      <a:r>
-                        <a:rPr b="1" sz="1600">
-                          <a:solidFill>
-                            <a:srgbClr val="FFFFFF"/>
-                          </a:solidFill>
-                        </a:rPr>
-                        <a:t>Input</a:t>
-                      </a:r>
-                    </a:p>
-                  </a:txBody>
-                  <a:tcPr>
-                    <a:solidFill>
-                      <a:srgbClr val="0072B2"/>
-                    </a:solidFill>
-                  </a:tcPr>
-                </a:tc>
-                <a:tc>
-                  <a:txBody>
-                    <a:bodyPr/>
-                    <a:lstStyle/>
-                    <a:p>
-                      <a:r>
-                        <a:rPr b="1" sz="1600">
-                          <a:solidFill>
-                            <a:srgbClr val="FFFFFF"/>
-                          </a:solidFill>
-                        </a:rPr>
-                        <a:t>Dataset</a:t>
-                      </a:r>
-                    </a:p>
-                  </a:txBody>
-                  <a:tcPr>
-                    <a:solidFill>
-                      <a:srgbClr val="0072B2"/>
-                    </a:solidFill>
-                  </a:tcPr>
-                </a:tc>
-                <a:tc>
-                  <a:txBody>
-                    <a:bodyPr/>
-                    <a:lstStyle/>
-                    <a:p>
-                      <a:r>
-                        <a:rPr b="1" sz="1600">
-                          <a:solidFill>
-                            <a:srgbClr val="FFFFFF"/>
-                          </a:solidFill>
-                        </a:rPr>
-                        <a:t>Accuracy (1 − MRE)</a:t>
-                      </a:r>
-                    </a:p>
-                  </a:txBody>
-                  <a:tcPr>
-                    <a:solidFill>
-                      <a:srgbClr val="0072B2"/>
-                    </a:solidFill>
-                  </a:tcPr>
-                </a:tc>
-              </a:tr>
-              <a:tr h="530352">
-                <a:tc>
-                  <a:txBody>
-                    <a:bodyPr/>
-                    <a:lstStyle/>
-                    <a:p>
-                      <a:r>
-                        <a:rPr sz="1500" b="0">
-                          <a:solidFill>
-                            <a:srgbClr val="1A1A1A"/>
-                          </a:solidFill>
-                        </a:rPr>
-                        <a:t>J₂ (this work, 42 feat)</a:t>
-                      </a:r>
-                    </a:p>
-                  </a:txBody>
-                  <a:tcPr>
-                    <a:solidFill>
-                      <a:srgbClr val="FFFFFF"/>
-                    </a:solidFill>
-                  </a:tcPr>
-                </a:tc>
-                <a:tc>
-                  <a:txBody>
-                    <a:bodyPr/>
-                    <a:lstStyle/>
-                    <a:p>
-                      <a:r>
-                        <a:rPr sz="1500" b="0">
-                          <a:solidFill>
-                            <a:srgbClr val="1A1A1A"/>
-                          </a:solidFill>
-                        </a:rPr>
-                        <a:t>≤13 cr., 12,955</a:t>
-                      </a:r>
-                    </a:p>
-                  </a:txBody>
-                  <a:tcPr>
-                    <a:solidFill>
-                      <a:srgbClr val="FFFFFF"/>
-                    </a:solidFill>
-                  </a:tcPr>
-                </a:tc>
-                <a:tc>
-                  <a:txBody>
-                    <a:bodyPr/>
-                    <a:lstStyle/>
-                    <a:p>
-                      <a:r>
-                        <a:rPr sz="1500" b="1">
-                          <a:solidFill>
-                            <a:srgbClr val="1A1A1A"/>
-                          </a:solidFill>
-                        </a:rPr>
-                        <a:t>96.9%</a:t>
-                      </a:r>
-                    </a:p>
-                  </a:txBody>
-                  <a:tcPr>
-                    <a:solidFill>
-                      <a:srgbClr val="FFFFFF"/>
-                    </a:solidFill>
-                  </a:tcPr>
-                </a:tc>
-              </a:tr>
-              <a:tr h="530352">
-                <a:tc>
-                  <a:txBody>
-                    <a:bodyPr/>
-                    <a:lstStyle/>
-                    <a:p>
-                      <a:r>
-                        <a:rPr sz="1500" b="1">
-                          <a:solidFill>
-                            <a:srgbClr val="D55E00"/>
-                          </a:solidFill>
-                        </a:rPr>
-                        <a:t>J₂ + phase (this work)</a:t>
-                      </a:r>
-                    </a:p>
-                  </a:txBody>
-                  <a:tcPr>
-                    <a:solidFill>
-                      <a:srgbClr val="FBE7D8"/>
-                    </a:solidFill>
-                  </a:tcPr>
-                </a:tc>
-                <a:tc>
-                  <a:txBody>
-                    <a:bodyPr/>
-                    <a:lstStyle/>
-                    <a:p>
-                      <a:r>
-                        <a:rPr sz="1500" b="1">
-                          <a:solidFill>
-                            <a:srgbClr val="D55E00"/>
-                          </a:solidFill>
-                        </a:rPr>
-                        <a:t>≤13 cr., 12,955</a:t>
-                      </a:r>
-                    </a:p>
-                  </a:txBody>
-                  <a:tcPr>
-                    <a:solidFill>
-                      <a:srgbClr val="FBE7D8"/>
-                    </a:solidFill>
-                  </a:tcPr>
-                </a:tc>
-                <a:tc>
-                  <a:txBody>
-                    <a:bodyPr/>
-                    <a:lstStyle/>
-                    <a:p>
-                      <a:r>
-                        <a:rPr sz="1500" b="1">
-                          <a:solidFill>
-                            <a:srgbClr val="D55E00"/>
-                          </a:solidFill>
-                        </a:rPr>
-                        <a:t>97.3%</a:t>
-                      </a:r>
-                    </a:p>
-                  </a:txBody>
-                  <a:tcPr>
-                    <a:solidFill>
-                      <a:srgbClr val="FBE7D8"/>
-                    </a:solidFill>
-                  </a:tcPr>
-                </a:tc>
-              </a:tr>
-              <a:tr h="530352">
-                <a:tc>
-                  <a:txBody>
-                    <a:bodyPr/>
-                    <a:lstStyle/>
-                    <a:p>
-                      <a:r>
-                        <a:rPr sz="1500" b="0">
-                          <a:solidFill>
-                            <a:srgbClr val="1A1A1A"/>
-                          </a:solidFill>
-                        </a:rPr>
-                        <a:t>J₂ (Hughes et al. 2025)</a:t>
-                      </a:r>
-                    </a:p>
-                  </a:txBody>
-                  <a:tcPr>
-                    <a:solidFill>
-                      <a:srgbClr val="FFFFFF"/>
-                    </a:solidFill>
-                  </a:tcPr>
-                </a:tc>
-                <a:tc>
-                  <a:txBody>
-                    <a:bodyPr/>
-                    <a:lstStyle/>
-                    <a:p>
-                      <a:r>
-                        <a:rPr sz="1500" b="0">
-                          <a:solidFill>
-                            <a:srgbClr val="1A1A1A"/>
-                          </a:solidFill>
-                        </a:rPr>
-                        <a:t>≤16 cr., 1.7M</a:t>
-                      </a:r>
-                    </a:p>
-                  </a:txBody>
-                  <a:tcPr>
-                    <a:solidFill>
-                      <a:srgbClr val="FFFFFF"/>
-                    </a:solidFill>
-                  </a:tcPr>
-                </a:tc>
-                <a:tc>
-                  <a:txBody>
-                    <a:bodyPr/>
-                    <a:lstStyle/>
-                    <a:p>
-                      <a:r>
-                        <a:rPr sz="1500" b="1">
-                          <a:solidFill>
-                            <a:srgbClr val="1A1A1A"/>
-                          </a:solidFill>
-                        </a:rPr>
-                        <a:t>98.5% — best J₂</a:t>
-                      </a:r>
-                    </a:p>
-                  </a:txBody>
-                  <a:tcPr>
-                    <a:solidFill>
-                      <a:srgbClr val="FFFFFF"/>
-                    </a:solidFill>
-                  </a:tcPr>
-                </a:tc>
-              </a:tr>
-              <a:tr h="530352">
-                <a:tc>
-                  <a:txBody>
-                    <a:bodyPr/>
-                    <a:lstStyle/>
-                    <a:p>
-                      <a:r>
-                        <a:rPr sz="1500" b="0">
-                          <a:solidFill>
-                            <a:srgbClr val="1A1A1A"/>
-                          </a:solidFill>
-                        </a:rPr>
-                        <a:t>J₃ adjoint (Hughes et al.)</a:t>
-                      </a:r>
-                    </a:p>
-                  </a:txBody>
-                  <a:tcPr>
-                    <a:solidFill>
-                      <a:srgbClr val="FFFFFF"/>
-                    </a:solidFill>
-                  </a:tcPr>
-                </a:tc>
-                <a:tc>
-                  <a:txBody>
-                    <a:bodyPr/>
-                    <a:lstStyle/>
-                    <a:p>
-                      <a:r>
-                        <a:rPr sz="1500" b="0">
-                          <a:solidFill>
-                            <a:srgbClr val="1A1A1A"/>
-                          </a:solidFill>
-                        </a:rPr>
-                        <a:t>≤15 cr., 177k</a:t>
-                      </a:r>
-                    </a:p>
-                  </a:txBody>
-                  <a:tcPr>
-                    <a:solidFill>
-                      <a:srgbClr val="FFFFFF"/>
-                    </a:solidFill>
-                  </a:tcPr>
-                </a:tc>
-                <a:tc>
-                  <a:txBody>
-                    <a:bodyPr/>
-                    <a:lstStyle/>
-                    <a:p>
-                      <a:r>
-                        <a:rPr sz="1500" b="1">
-                          <a:solidFill>
-                            <a:srgbClr val="1A1A1A"/>
-                          </a:solidFill>
-                        </a:rPr>
-                        <a:t>99.3% — highest</a:t>
-                      </a:r>
-                    </a:p>
-                  </a:txBody>
-                  <a:tcPr>
-                    <a:solidFill>
-                      <a:srgbClr val="FFFFFF"/>
-                    </a:solidFill>
-                  </a:tcPr>
-                </a:tc>
-              </a:tr>
-            </a:tbl>
-          </a:graphicData>
-        </a:graphic>
-      </p:graphicFrame>
+        </p:nvPicPr>
+        <p:blipFill>
+          <a:blip r:embed="rId2"/>
+          <a:stretch>
+            <a:fillRect/>
+          </a:stretch>
+        </p:blipFill>
+        <p:spPr>
+          <a:xfrm>
+            <a:off x="792327" y="1143000"/>
+            <a:ext cx="10607040" cy="4209370"/>
+          </a:xfrm>
+          <a:prstGeom prst="rect">
+            <a:avLst/>
+          </a:prstGeom>
+        </p:spPr>
+      </p:pic>
       <p:sp>
         <p:nvSpPr>
           <p:cNvPr id="5" name="TextBox 4"/>
@@ -7236,8 +7939,8 @@
         </p:nvSpPr>
         <p:spPr>
           <a:xfrm>
-            <a:off x="640080" y="4297680"/>
-            <a:ext cx="10972800" cy="2194560"/>
+            <a:off x="640080" y="5989320"/>
+            <a:ext cx="10972800" cy="640080"/>
           </a:xfrm>
           <a:prstGeom prst="rect">
             <a:avLst/>
@@ -7250,78 +7953,19 @@
           </a:bodyPr>
           <a:lstStyle/>
           <a:p>
-            <a:pPr>
+            <a:pPr algn="ctr">
               <a:spcAft>
-                <a:spcPts val="1200"/>
+                <a:spcPts val="800"/>
               </a:spcAft>
             </a:pPr>
             <a:r>
-              <a:rPr b="1" sz="1900">
-                <a:solidFill>
-                  <a:srgbClr val="D55E00"/>
+              <a:rPr sz="1600" b="1" i="0">
+                <a:solidFill>
+                  <a:srgbClr val="0072B2"/>
                 </a:solidFill>
                 <a:latin typeface="Calibri"/>
               </a:rPr>
-              <a:t>Takeaway.  </a:t>
-            </a:r>
-            <a:r>
-              <a:rPr sz="1900">
-                <a:solidFill>
-                  <a:srgbClr val="1A1A1A"/>
-                </a:solidFill>
-                <a:latin typeface="Calibri"/>
-              </a:rPr>
-              <a:t>A theory-motivated feature bought a real, budget-matched gain — for free, at every model size.</a:t>
-            </a:r>
-          </a:p>
-          <a:p>
-            <a:pPr>
-              <a:spcAft>
-                <a:spcPts val="1200"/>
-              </a:spcAft>
-            </a:pPr>
-            <a:r>
-              <a:rPr b="1" sz="1900">
-                <a:solidFill>
-                  <a:srgbClr val="1A1A1A"/>
-                </a:solidFill>
-                <a:latin typeface="Calibri"/>
-              </a:rPr>
-              <a:t>Ceiling.  </a:t>
-            </a:r>
-            <a:r>
-              <a:rPr sz="1900">
-                <a:solidFill>
-                  <a:srgbClr val="1A1A1A"/>
-                </a:solidFill>
-                <a:latin typeface="Calibri"/>
-              </a:rPr>
-              <a:t>But ~98.5% is set by the data: distinct knots share a J₂ yet differ ~3% in volume. No architecture resolves them.</a:t>
-            </a:r>
-          </a:p>
-          <a:p>
-            <a:pPr>
-              <a:spcAft>
-                <a:spcPts val="1200"/>
-              </a:spcAft>
-            </a:pPr>
-            <a:r>
-              <a:rPr b="1" sz="1900">
-                <a:solidFill>
-                  <a:srgbClr val="1A1A1A"/>
-                </a:solidFill>
-                <a:latin typeface="Calibri"/>
-              </a:rPr>
-              <a:t>Next.  </a:t>
-            </a:r>
-            <a:r>
-              <a:rPr sz="1900">
-                <a:solidFill>
-                  <a:srgbClr val="1A1A1A"/>
-                </a:solidFill>
-                <a:latin typeface="Calibri"/>
-              </a:rPr>
-              <a:t>Measured in Part II: on a matched 1,419-knot set, the adjoint J₃ more than halves the error of J₂ — the ceiling is real and J₃ breaks it.</a:t>
+              <a:t>Found by the 45-feature (phase) search: 45→32→18→54→18→1 GELU MLP, 4,101 params (lr 6.4e-3, dropout 0.006, L2 1e-6, batch 256) — test MRE 0.0289 ± 0.0004, ensemble 0.0269 (97.31%). Tiny, because the phase feature hands even a small net a near-direct line to the volume.</a:t>
             </a:r>
           </a:p>
         </p:txBody>
@@ -7652,4 +8296,324 @@
   </a:objectDefaults>
   <a:extraClrSchemeLst/>
 </a:theme>
+</file>
+
+<file path=ppt/theme/theme2.xml><?xml version="1.0" encoding="utf-8"?>
+<a:theme xmlns:a="http://schemas.openxmlformats.org/drawingml/2006/main" name="Office Theme">
+  <a:themeElements>
+    <a:clrScheme name="Office">
+      <a:dk1>
+        <a:sysClr val="windowText" lastClr="000000"/>
+      </a:dk1>
+      <a:lt1>
+        <a:sysClr val="window" lastClr="FFFFFF"/>
+      </a:lt1>
+      <a:dk2>
+        <a:srgbClr val="1F497D"/>
+      </a:dk2>
+      <a:lt2>
+        <a:srgbClr val="EEECE1"/>
+      </a:lt2>
+      <a:accent1>
+        <a:srgbClr val="4F81BD"/>
+      </a:accent1>
+      <a:accent2>
+        <a:srgbClr val="C0504D"/>
+      </a:accent2>
+      <a:accent3>
+        <a:srgbClr val="9BBB59"/>
+      </a:accent3>
+      <a:accent4>
+        <a:srgbClr val="8064A2"/>
+      </a:accent4>
+      <a:accent5>
+        <a:srgbClr val="4BACC6"/>
+      </a:accent5>
+      <a:accent6>
+        <a:srgbClr val="F79646"/>
+      </a:accent6>
+      <a:hlink>
+        <a:srgbClr val="0000FF"/>
+      </a:hlink>
+      <a:folHlink>
+        <a:srgbClr val="800080"/>
+      </a:folHlink>
+    </a:clrScheme>
+    <a:fontScheme name="Office">
+      <a:majorFont>
+        <a:latin typeface="Calibri"/>
+        <a:ea typeface=""/>
+        <a:cs typeface=""/>
+        <a:font script="Jpan" typeface="ＭＳ Ｐゴシック"/>
+        <a:font script="Hang" typeface="맑은 고딕"/>
+        <a:font script="Hans" typeface="宋体"/>
+        <a:font script="Hant" typeface="新細明體"/>
+        <a:font script="Arab" typeface="Times New Roman"/>
+        <a:font script="Hebr" typeface="Times New Roman"/>
+        <a:font script="Thai" typeface="Angsana New"/>
+        <a:font script="Ethi" typeface="Nyala"/>
+        <a:font script="Beng" typeface="Vrinda"/>
+        <a:font script="Gujr" typeface="Shruti"/>
+        <a:font script="Khmr" typeface="MoolBoran"/>
+        <a:font script="Knda" typeface="Tunga"/>
+        <a:font script="Guru" typeface="Raavi"/>
+        <a:font script="Cans" typeface="Euphemia"/>
+        <a:font script="Cher" typeface="Plantagenet Cherokee"/>
+        <a:font script="Yiii" typeface="Microsoft Yi Baiti"/>
+        <a:font script="Tibt" typeface="Microsoft Himalaya"/>
+        <a:font script="Thaa" typeface="MV Boli"/>
+        <a:font script="Deva" typeface="Mangal"/>
+        <a:font script="Telu" typeface="Gautami"/>
+        <a:font script="Taml" typeface="Latha"/>
+        <a:font script="Syrc" typeface="Estrangelo Edessa"/>
+        <a:font script="Orya" typeface="Kalinga"/>
+        <a:font script="Mlym" typeface="Kartika"/>
+        <a:font script="Laoo" typeface="DokChampa"/>
+        <a:font script="Sinh" typeface="Iskoola Pota"/>
+        <a:font script="Mong" typeface="Mongolian Baiti"/>
+        <a:font script="Viet" typeface="Times New Roman"/>
+        <a:font script="Uigh" typeface="Microsoft Uighur"/>
+        <a:font script="Geor" typeface="Sylfaen"/>
+      </a:majorFont>
+      <a:minorFont>
+        <a:latin typeface="Calibri"/>
+        <a:ea typeface=""/>
+        <a:cs typeface=""/>
+        <a:font script="Jpan" typeface="ＭＳ Ｐゴシック"/>
+        <a:font script="Hang" typeface="맑은 고딕"/>
+        <a:font script="Hans" typeface="宋体"/>
+        <a:font script="Hant" typeface="新細明體"/>
+        <a:font script="Arab" typeface="Arial"/>
+        <a:font script="Hebr" typeface="Arial"/>
+        <a:font script="Thai" typeface="Cordia New"/>
+        <a:font script="Ethi" typeface="Nyala"/>
+        <a:font script="Beng" typeface="Vrinda"/>
+        <a:font script="Gujr" typeface="Shruti"/>
+        <a:font script="Khmr" typeface="DaunPenh"/>
+        <a:font script="Knda" typeface="Tunga"/>
+        <a:font script="Guru" typeface="Raavi"/>
+        <a:font script="Cans" typeface="Euphemia"/>
+        <a:font script="Cher" typeface="Plantagenet Cherokee"/>
+        <a:font script="Yiii" typeface="Microsoft Yi Baiti"/>
+        <a:font script="Tibt" typeface="Microsoft Himalaya"/>
+        <a:font script="Thaa" typeface="MV Boli"/>
+        <a:font script="Deva" typeface="Mangal"/>
+        <a:font script="Telu" typeface="Gautami"/>
+        <a:font script="Taml" typeface="Latha"/>
+        <a:font script="Syrc" typeface="Estrangelo Edessa"/>
+        <a:font script="Orya" typeface="Kalinga"/>
+        <a:font script="Mlym" typeface="Kartika"/>
+        <a:font script="Laoo" typeface="DokChampa"/>
+        <a:font script="Sinh" typeface="Iskoola Pota"/>
+        <a:font script="Mong" typeface="Mongolian Baiti"/>
+        <a:font script="Viet" typeface="Arial"/>
+        <a:font script="Uigh" typeface="Microsoft Uighur"/>
+        <a:font script="Geor" typeface="Sylfaen"/>
+      </a:minorFont>
+    </a:fontScheme>
+    <a:fmtScheme name="Office">
+      <a:fillStyleLst>
+        <a:solidFill>
+          <a:schemeClr val="phClr"/>
+        </a:solidFill>
+        <a:gradFill rotWithShape="1">
+          <a:gsLst>
+            <a:gs pos="0">
+              <a:schemeClr val="phClr">
+                <a:tint val="50000"/>
+                <a:satMod val="300000"/>
+              </a:schemeClr>
+            </a:gs>
+            <a:gs pos="35000">
+              <a:schemeClr val="phClr">
+                <a:tint val="37000"/>
+                <a:satMod val="300000"/>
+              </a:schemeClr>
+            </a:gs>
+            <a:gs pos="100000">
+              <a:schemeClr val="phClr">
+                <a:tint val="15000"/>
+                <a:satMod val="350000"/>
+              </a:schemeClr>
+            </a:gs>
+          </a:gsLst>
+          <a:lin ang="16200000" scaled="1"/>
+        </a:gradFill>
+        <a:gradFill rotWithShape="1">
+          <a:gsLst>
+            <a:gs pos="0">
+              <a:schemeClr val="phClr">
+                <a:tint val="100000"/>
+                <a:shade val="100000"/>
+                <a:satMod val="130000"/>
+              </a:schemeClr>
+            </a:gs>
+            <a:gs pos="100000">
+              <a:schemeClr val="phClr">
+                <a:tint val="50000"/>
+                <a:shade val="100000"/>
+                <a:satMod val="350000"/>
+              </a:schemeClr>
+            </a:gs>
+          </a:gsLst>
+          <a:lin ang="16200000" scaled="0"/>
+        </a:gradFill>
+      </a:fillStyleLst>
+      <a:lnStyleLst>
+        <a:ln w="9525" cap="flat" cmpd="sng" algn="ctr">
+          <a:solidFill>
+            <a:schemeClr val="phClr">
+              <a:shade val="95000"/>
+              <a:satMod val="105000"/>
+            </a:schemeClr>
+          </a:solidFill>
+          <a:prstDash val="solid"/>
+        </a:ln>
+        <a:ln w="25400" cap="flat" cmpd="sng" algn="ctr">
+          <a:solidFill>
+            <a:schemeClr val="phClr"/>
+          </a:solidFill>
+          <a:prstDash val="solid"/>
+        </a:ln>
+        <a:ln w="38100" cap="flat" cmpd="sng" algn="ctr">
+          <a:solidFill>
+            <a:schemeClr val="phClr"/>
+          </a:solidFill>
+          <a:prstDash val="solid"/>
+        </a:ln>
+      </a:lnStyleLst>
+      <a:effectStyleLst>
+        <a:effectStyle>
+          <a:effectLst>
+            <a:outerShdw blurRad="40000" dist="20000" dir="5400000" rotWithShape="0">
+              <a:srgbClr val="000000">
+                <a:alpha val="38000"/>
+              </a:srgbClr>
+            </a:outerShdw>
+          </a:effectLst>
+        </a:effectStyle>
+        <a:effectStyle>
+          <a:effectLst>
+            <a:outerShdw blurRad="40000" dist="23000" dir="5400000" rotWithShape="0">
+              <a:srgbClr val="000000">
+                <a:alpha val="35000"/>
+              </a:srgbClr>
+            </a:outerShdw>
+          </a:effectLst>
+        </a:effectStyle>
+        <a:effectStyle>
+          <a:effectLst>
+            <a:outerShdw blurRad="40000" dist="23000" dir="5400000" rotWithShape="0">
+              <a:srgbClr val="000000">
+                <a:alpha val="35000"/>
+              </a:srgbClr>
+            </a:outerShdw>
+          </a:effectLst>
+          <a:scene3d>
+            <a:camera prst="orthographicFront">
+              <a:rot lat="0" lon="0" rev="0"/>
+            </a:camera>
+            <a:lightRig rig="threePt" dir="t">
+              <a:rot lat="0" lon="0" rev="1200000"/>
+            </a:lightRig>
+          </a:scene3d>
+          <a:sp3d>
+            <a:bevelT w="63500" h="25400"/>
+          </a:sp3d>
+        </a:effectStyle>
+      </a:effectStyleLst>
+      <a:bgFillStyleLst>
+        <a:solidFill>
+          <a:schemeClr val="phClr"/>
+        </a:solidFill>
+        <a:gradFill rotWithShape="1">
+          <a:gsLst>
+            <a:gs pos="0">
+              <a:schemeClr val="phClr">
+                <a:tint val="40000"/>
+                <a:satMod val="350000"/>
+              </a:schemeClr>
+            </a:gs>
+            <a:gs pos="40000">
+              <a:schemeClr val="phClr">
+                <a:tint val="45000"/>
+                <a:shade val="99000"/>
+                <a:satMod val="350000"/>
+              </a:schemeClr>
+            </a:gs>
+            <a:gs pos="100000">
+              <a:schemeClr val="phClr">
+                <a:shade val="20000"/>
+                <a:satMod val="255000"/>
+              </a:schemeClr>
+            </a:gs>
+          </a:gsLst>
+          <a:path path="circle">
+            <a:fillToRect l="50000" t="-80000" r="50000" b="180000"/>
+          </a:path>
+        </a:gradFill>
+        <a:gradFill rotWithShape="1">
+          <a:gsLst>
+            <a:gs pos="0">
+              <a:schemeClr val="phClr">
+                <a:tint val="80000"/>
+                <a:satMod val="300000"/>
+              </a:schemeClr>
+            </a:gs>
+            <a:gs pos="100000">
+              <a:schemeClr val="phClr">
+                <a:shade val="30000"/>
+                <a:satMod val="200000"/>
+              </a:schemeClr>
+            </a:gs>
+          </a:gsLst>
+          <a:path path="circle">
+            <a:fillToRect l="50000" t="50000" r="50000" b="50000"/>
+          </a:path>
+        </a:gradFill>
+      </a:bgFillStyleLst>
+    </a:fmtScheme>
+  </a:themeElements>
+  <a:objectDefaults>
+    <a:spDef>
+      <a:spPr/>
+      <a:bodyPr/>
+      <a:lstStyle/>
+      <a:style>
+        <a:lnRef idx="1">
+          <a:schemeClr val="accent1"/>
+        </a:lnRef>
+        <a:fillRef idx="3">
+          <a:schemeClr val="accent1"/>
+        </a:fillRef>
+        <a:effectRef idx="2">
+          <a:schemeClr val="accent1"/>
+        </a:effectRef>
+        <a:fontRef idx="minor">
+          <a:schemeClr val="lt1"/>
+        </a:fontRef>
+      </a:style>
+    </a:spDef>
+    <a:lnDef>
+      <a:spPr/>
+      <a:bodyPr/>
+      <a:lstStyle/>
+      <a:style>
+        <a:lnRef idx="2">
+          <a:schemeClr val="accent1"/>
+        </a:lnRef>
+        <a:fillRef idx="0">
+          <a:schemeClr val="accent1"/>
+        </a:fillRef>
+        <a:effectRef idx="1">
+          <a:schemeClr val="accent1"/>
+        </a:effectRef>
+        <a:fontRef idx="minor">
+          <a:schemeClr val="tx1"/>
+        </a:fontRef>
+      </a:style>
+    </a:lnDef>
+  </a:objectDefaults>
+  <a:extraClrSchemeLst/>
+</a:theme>
 </file>
</xml_diff>